<commit_message>
Simplify the "Inheritance in action" slide
- Drop PBS from this one slide (it's about inheritance, not scheduling).
- base now owns a variable (threads: 2); small is just inherits_from: base.
- large overrides only the variable (threads: 5); debug overrides only the
  build with a realistic flag (-fsanitize=address, not a weak -O0).
- Block YAML throughout — no confusing inline {...} braces.

Co-Authored-By: Claude Opus 4.8 (1M context) <noreply@anthropic.com>
</commit_message>
<xml_diff>
--- a/pavilion-workshop.pptx
+++ b/pavilion-workshop.pptx
@@ -3140,7 +3140,7 @@
           <a:lstStyle/>
           <a:p>
             <a:r>
-              <a:t>One base, three variants — each inherits_from base and overrides only its delta (threads, node count, build flags). Verified live: a child inherits the parent's PBS scheduler and overrides its own variables. The DRY win.</a:t>
+              <a:t>One base owns the shared config and a variable (threads: 2). 'small' is literally just inherits_from: base — it takes everything. 'large' inherits and overrides only the variable (threads: 5). 'debug' inherits and overrides only the build, adding -fsanitize=address. Each child writes just its delta — that's the DRY win.</a:t>
             </a:r>
           </a:p>
         </p:txBody>
@@ -7057,43 +7057,43 @@
           <a:p>
             <a:pPr algn="l"/>
             <a:r>
-              <a:rPr sz="1350" b="0">
+              <a:rPr sz="1400" b="0">
                 <a:solidFill>
                   <a:srgbClr val="1B2B34"/>
                 </a:solidFill>
                 <a:latin typeface="Consolas"/>
               </a:rPr>
-              <a:t>base:                          # shared config lives here, once</a:t>
-            </a:r>
-          </a:p>
-          <a:p>
-            <a:pPr algn="l"/>
-            <a:r>
-              <a:rPr sz="1350" b="0">
+              <a:t>base:                          # shared config, written once</a:t>
+            </a:r>
+          </a:p>
+          <a:p>
+            <a:pPr algn="l"/>
+            <a:r>
+              <a:rPr sz="1400" b="0">
                 <a:solidFill>
                   <a:srgbClr val="1B2B34"/>
                 </a:solidFill>
                 <a:latin typeface="Consolas"/>
               </a:rPr>
-              <a:t>  scheduler: pbs</a:t>
-            </a:r>
-          </a:p>
-          <a:p>
-            <a:pPr algn="l"/>
-            <a:r>
-              <a:rPr sz="1350" b="0">
+              <a:t>  variables:</a:t>
+            </a:r>
+          </a:p>
+          <a:p>
+            <a:pPr algn="l"/>
+            <a:r>
+              <a:rPr sz="1400" b="0">
                 <a:solidFill>
                   <a:srgbClr val="1B2B34"/>
                 </a:solidFill>
                 <a:latin typeface="Consolas"/>
               </a:rPr>
-              <a:t>  schedule: {pbs: {queue: workq, nodes: 1}}</a:t>
-            </a:r>
-          </a:p>
-          <a:p>
-            <a:pPr algn="l"/>
-            <a:r>
-              <a:rPr sz="1350" b="0">
+              <a:t>    threads: 2</a:t>
+            </a:r>
+          </a:p>
+          <a:p>
+            <a:pPr algn="l"/>
+            <a:r>
+              <a:rPr sz="1400" b="0">
                 <a:solidFill>
                   <a:srgbClr val="1B2B34"/>
                 </a:solidFill>
@@ -7105,7 +7105,7 @@
           <a:p>
             <a:pPr algn="l"/>
             <a:r>
-              <a:rPr sz="1350" b="0">
+              <a:rPr sz="1400" b="0">
                 <a:solidFill>
                   <a:srgbClr val="1B2B34"/>
                 </a:solidFill>
@@ -7117,55 +7117,79 @@
           <a:p>
             <a:pPr algn="l"/>
             <a:r>
-              <a:rPr sz="1350" b="0">
+              <a:rPr sz="1400" b="0">
                 <a:solidFill>
                   <a:srgbClr val="1B2B34"/>
                 </a:solidFill>
                 <a:latin typeface="Consolas"/>
               </a:rPr>
-              <a:t>    cmds: ['gcc -O3 -fopenmp stream.c -o stream']</a:t>
-            </a:r>
-          </a:p>
-          <a:p>
-            <a:pPr algn="l"/>
-            <a:r>
-              <a:rPr sz="1350" b="0">
+              <a:t>    cmds:</a:t>
+            </a:r>
+          </a:p>
+          <a:p>
+            <a:pPr algn="l"/>
+            <a:r>
+              <a:rPr sz="1400" b="0">
                 <a:solidFill>
                   <a:srgbClr val="1B2B34"/>
                 </a:solidFill>
                 <a:latin typeface="Consolas"/>
               </a:rPr>
+              <a:t>      - 'gcc -O3 -fopenmp stream.c -o stream'</a:t>
+            </a:r>
+          </a:p>
+          <a:p>
+            <a:pPr algn="l"/>
+            <a:r>
+              <a:rPr sz="1400" b="0">
+                <a:solidFill>
+                  <a:srgbClr val="1B2B34"/>
+                </a:solidFill>
+                <a:latin typeface="Consolas"/>
+              </a:rPr>
               <a:t>  run:</a:t>
             </a:r>
           </a:p>
           <a:p>
             <a:pPr algn="l"/>
             <a:r>
-              <a:rPr sz="1350" b="0">
+              <a:rPr sz="1400" b="0">
                 <a:solidFill>
                   <a:srgbClr val="1B2B34"/>
                 </a:solidFill>
                 <a:latin typeface="Consolas"/>
               </a:rPr>
-              <a:t>    cmds: ['./stream']</a:t>
-            </a:r>
-          </a:p>
-          <a:p>
-            <a:pPr algn="l"/>
-            <a:r>
-              <a:rPr sz="1350" b="0">
+              <a:t>    cmds:</a:t>
+            </a:r>
+          </a:p>
+          <a:p>
+            <a:pPr algn="l"/>
+            <a:r>
+              <a:rPr sz="1400" b="0">
                 <a:solidFill>
                   <a:srgbClr val="1B2B34"/>
                 </a:solidFill>
                 <a:latin typeface="Consolas"/>
               </a:rPr>
+              <a:t>      - 'OMP_NUM_THREADS={{threads}} ./stream'</a:t>
+            </a:r>
+          </a:p>
+          <a:p>
+            <a:pPr algn="l"/>
+            <a:r>
+              <a:rPr sz="1400" b="0">
+                <a:solidFill>
+                  <a:srgbClr val="1B2B34"/>
+                </a:solidFill>
+                <a:latin typeface="Consolas"/>
+              </a:rPr>
               <a:t> </a:t>
             </a:r>
           </a:p>
           <a:p>
             <a:pPr algn="l"/>
             <a:r>
-              <a:rPr sz="1350" b="0">
+              <a:rPr sz="1400" b="0">
                 <a:solidFill>
                   <a:srgbClr val="1B2B34"/>
                 </a:solidFill>
@@ -7177,55 +7201,103 @@
           <a:p>
             <a:pPr algn="l"/>
             <a:r>
-              <a:rPr sz="1350" b="0">
+              <a:rPr sz="1400" b="0">
                 <a:solidFill>
                   <a:srgbClr val="1B2B34"/>
                 </a:solidFill>
                 <a:latin typeface="Consolas"/>
               </a:rPr>
+              <a:t>  inherits_from: base          # that's it — inherits everything</a:t>
+            </a:r>
+          </a:p>
+          <a:p>
+            <a:pPr algn="l"/>
+            <a:r>
+              <a:rPr sz="1400" b="0">
+                <a:solidFill>
+                  <a:srgbClr val="1B2B34"/>
+                </a:solidFill>
+                <a:latin typeface="Consolas"/>
+              </a:rPr>
+              <a:t> </a:t>
+            </a:r>
+          </a:p>
+          <a:p>
+            <a:pPr algn="l"/>
+            <a:r>
+              <a:rPr sz="1400" b="0">
+                <a:solidFill>
+                  <a:srgbClr val="1B2B34"/>
+                </a:solidFill>
+                <a:latin typeface="Consolas"/>
+              </a:rPr>
+              <a:t>large:</a:t>
+            </a:r>
+          </a:p>
+          <a:p>
+            <a:pPr algn="l"/>
+            <a:r>
+              <a:rPr sz="1400" b="0">
+                <a:solidFill>
+                  <a:srgbClr val="1B2B34"/>
+                </a:solidFill>
+                <a:latin typeface="Consolas"/>
+              </a:rPr>
               <a:t>  inherits_from: base</a:t>
             </a:r>
           </a:p>
           <a:p>
             <a:pPr algn="l"/>
             <a:r>
-              <a:rPr sz="1350" b="0">
+              <a:rPr sz="1400" b="0">
                 <a:solidFill>
                   <a:srgbClr val="1B2B34"/>
                 </a:solidFill>
                 <a:latin typeface="Consolas"/>
               </a:rPr>
-              <a:t>  variables: {threads: 1}                 # override just this</a:t>
-            </a:r>
-          </a:p>
-          <a:p>
-            <a:pPr algn="l"/>
-            <a:r>
-              <a:rPr sz="1350" b="0">
+              <a:t>  variables:</a:t>
+            </a:r>
+          </a:p>
+          <a:p>
+            <a:pPr algn="l"/>
+            <a:r>
+              <a:rPr sz="1400" b="0">
                 <a:solidFill>
                   <a:srgbClr val="1B2B34"/>
                 </a:solidFill>
                 <a:latin typeface="Consolas"/>
               </a:rPr>
+              <a:t>    threads: 5                 # override just the variable</a:t>
+            </a:r>
+          </a:p>
+          <a:p>
+            <a:pPr algn="l"/>
+            <a:r>
+              <a:rPr sz="1400" b="0">
+                <a:solidFill>
+                  <a:srgbClr val="1B2B34"/>
+                </a:solidFill>
+                <a:latin typeface="Consolas"/>
+              </a:rPr>
               <a:t> </a:t>
             </a:r>
           </a:p>
           <a:p>
             <a:pPr algn="l"/>
             <a:r>
-              <a:rPr sz="1350" b="0">
+              <a:rPr sz="1400" b="0">
                 <a:solidFill>
                   <a:srgbClr val="1B2B34"/>
                 </a:solidFill>
                 <a:latin typeface="Consolas"/>
               </a:rPr>
-              <a:t>large:</a:t>
-            </a:r>
-          </a:p>
-          <a:p>
-            <a:pPr algn="l"/>
-            <a:r>
-              <a:rPr sz="1350" b="0">
+              <a:t>debug:</a:t>
+            </a:r>
+          </a:p>
+          <a:p>
+            <a:pPr algn="l"/>
+            <a:r>
+              <a:rPr sz="1400" b="0">
                 <a:solidFill>
                   <a:srgbClr val="1B2B34"/>
                 </a:solidFill>
@@ -7237,61 +7309,37 @@
           <a:p>
             <a:pPr algn="l"/>
             <a:r>
-              <a:rPr sz="1350" b="0">
+              <a:rPr sz="1400" b="0">
                 <a:solidFill>
                   <a:srgbClr val="1B2B34"/>
                 </a:solidFill>
                 <a:latin typeface="Consolas"/>
               </a:rPr>
-              <a:t>  schedule: {pbs: {nodes: 4}}             # override the node count</a:t>
-            </a:r>
-          </a:p>
-          <a:p>
-            <a:pPr algn="l"/>
-            <a:r>
-              <a:rPr sz="1350" b="0">
+              <a:t>  build:</a:t>
+            </a:r>
+          </a:p>
+          <a:p>
+            <a:pPr algn="l"/>
+            <a:r>
+              <a:rPr sz="1400" b="0">
                 <a:solidFill>
                   <a:srgbClr val="1B2B34"/>
                 </a:solidFill>
                 <a:latin typeface="Consolas"/>
               </a:rPr>
-              <a:t> </a:t>
-            </a:r>
-          </a:p>
-          <a:p>
-            <a:pPr algn="l"/>
-            <a:r>
-              <a:rPr sz="1350" b="0">
+              <a:t>    cmds:</a:t>
+            </a:r>
+          </a:p>
+          <a:p>
+            <a:pPr algn="l"/>
+            <a:r>
+              <a:rPr sz="1400" b="0">
                 <a:solidFill>
                   <a:srgbClr val="1B2B34"/>
                 </a:solidFill>
                 <a:latin typeface="Consolas"/>
               </a:rPr>
-              <a:t>debug:</a:t>
-            </a:r>
-          </a:p>
-          <a:p>
-            <a:pPr algn="l"/>
-            <a:r>
-              <a:rPr sz="1350" b="0">
-                <a:solidFill>
-                  <a:srgbClr val="1B2B34"/>
-                </a:solidFill>
-                <a:latin typeface="Consolas"/>
-              </a:rPr>
-              <a:t>  inherits_from: base</a:t>
-            </a:r>
-          </a:p>
-          <a:p>
-            <a:pPr algn="l"/>
-            <a:r>
-              <a:rPr sz="1350" b="0">
-                <a:solidFill>
-                  <a:srgbClr val="1B2B34"/>
-                </a:solidFill>
-                <a:latin typeface="Consolas"/>
-              </a:rPr>
-              <a:t>  build: {cmds: ['gcc -O0 -g stream.c -o stream']}   # override the build</a:t>
+              <a:t>      - 'gcc -O3 -fopenmp -fsanitize=address stream.c -o stream'   # override the build</a:t>
             </a:r>
           </a:p>
         </p:txBody>

</xml_diff>

<commit_message>
Fix inheritance slide overflow: shrink font, grow box, trim to 20 lines
Content was 24 lines at 14pt and spilled past the code box. Dropped
source_path, collapsed base build/run to single-line cmds lists, set
code_size 12.5 / code_h 5.45. Rendered slide 12 to confirm it fits.

Co-Authored-By: Claude Opus 4.8 (1M context) <noreply@anthropic.com>
</commit_message>
<xml_diff>
--- a/pavilion-workshop.pptx
+++ b/pavilion-workshop.pptx
@@ -7023,7 +7023,7 @@
         <p:spPr>
           <a:xfrm>
             <a:off x="640080" y="1783080"/>
-            <a:ext cx="10972800" cy="4572000"/>
+            <a:ext cx="10972800" cy="4983480"/>
           </a:xfrm>
           <a:prstGeom prst="rect">
             <a:avLst/>
@@ -7057,19 +7057,19 @@
           <a:p>
             <a:pPr algn="l"/>
             <a:r>
-              <a:rPr sz="1400" b="0">
+              <a:rPr sz="1250" b="0">
                 <a:solidFill>
                   <a:srgbClr val="1B2B34"/>
                 </a:solidFill>
                 <a:latin typeface="Consolas"/>
               </a:rPr>
-              <a:t>base:                          # shared config, written once</a:t>
-            </a:r>
-          </a:p>
-          <a:p>
-            <a:pPr algn="l"/>
-            <a:r>
-              <a:rPr sz="1400" b="0">
+              <a:t>base:                        # shared config, written once</a:t>
+            </a:r>
+          </a:p>
+          <a:p>
+            <a:pPr algn="l"/>
+            <a:r>
+              <a:rPr sz="1250" b="0">
                 <a:solidFill>
                   <a:srgbClr val="1B2B34"/>
                 </a:solidFill>
@@ -7081,7 +7081,7 @@
           <a:p>
             <a:pPr algn="l"/>
             <a:r>
-              <a:rPr sz="1400" b="0">
+              <a:rPr sz="1250" b="0">
                 <a:solidFill>
                   <a:srgbClr val="1B2B34"/>
                 </a:solidFill>
@@ -7093,7 +7093,7 @@
           <a:p>
             <a:pPr algn="l"/>
             <a:r>
-              <a:rPr sz="1400" b="0">
+              <a:rPr sz="1250" b="0">
                 <a:solidFill>
                   <a:srgbClr val="1B2B34"/>
                 </a:solidFill>
@@ -7105,79 +7105,79 @@
           <a:p>
             <a:pPr algn="l"/>
             <a:r>
-              <a:rPr sz="1400" b="0">
+              <a:rPr sz="1250" b="0">
                 <a:solidFill>
                   <a:srgbClr val="1B2B34"/>
                 </a:solidFill>
                 <a:latin typeface="Consolas"/>
               </a:rPr>
-              <a:t>    source_path: stream.c</a:t>
-            </a:r>
-          </a:p>
-          <a:p>
-            <a:pPr algn="l"/>
-            <a:r>
-              <a:rPr sz="1400" b="0">
+              <a:t>    cmds: ['gcc -O3 -fopenmp stream.c -o stream']</a:t>
+            </a:r>
+          </a:p>
+          <a:p>
+            <a:pPr algn="l"/>
+            <a:r>
+              <a:rPr sz="1250" b="0">
                 <a:solidFill>
                   <a:srgbClr val="1B2B34"/>
                 </a:solidFill>
                 <a:latin typeface="Consolas"/>
               </a:rPr>
-              <a:t>    cmds:</a:t>
-            </a:r>
-          </a:p>
-          <a:p>
-            <a:pPr algn="l"/>
-            <a:r>
-              <a:rPr sz="1400" b="0">
+              <a:t>  run:</a:t>
+            </a:r>
+          </a:p>
+          <a:p>
+            <a:pPr algn="l"/>
+            <a:r>
+              <a:rPr sz="1250" b="0">
                 <a:solidFill>
                   <a:srgbClr val="1B2B34"/>
                 </a:solidFill>
                 <a:latin typeface="Consolas"/>
               </a:rPr>
-              <a:t>      - 'gcc -O3 -fopenmp stream.c -o stream'</a:t>
-            </a:r>
-          </a:p>
-          <a:p>
-            <a:pPr algn="l"/>
-            <a:r>
-              <a:rPr sz="1400" b="0">
+              <a:t>    cmds: ['OMP_NUM_THREADS={{threads}} ./stream']</a:t>
+            </a:r>
+          </a:p>
+          <a:p>
+            <a:pPr algn="l"/>
+            <a:r>
+              <a:rPr sz="1250" b="0">
                 <a:solidFill>
                   <a:srgbClr val="1B2B34"/>
                 </a:solidFill>
                 <a:latin typeface="Consolas"/>
               </a:rPr>
-              <a:t>  run:</a:t>
-            </a:r>
-          </a:p>
-          <a:p>
-            <a:pPr algn="l"/>
-            <a:r>
-              <a:rPr sz="1400" b="0">
+              <a:t> </a:t>
+            </a:r>
+          </a:p>
+          <a:p>
+            <a:pPr algn="l"/>
+            <a:r>
+              <a:rPr sz="1250" b="0">
                 <a:solidFill>
                   <a:srgbClr val="1B2B34"/>
                 </a:solidFill>
                 <a:latin typeface="Consolas"/>
               </a:rPr>
-              <a:t>    cmds:</a:t>
-            </a:r>
-          </a:p>
-          <a:p>
-            <a:pPr algn="l"/>
-            <a:r>
-              <a:rPr sz="1400" b="0">
+              <a:t>small:</a:t>
+            </a:r>
+          </a:p>
+          <a:p>
+            <a:pPr algn="l"/>
+            <a:r>
+              <a:rPr sz="1250" b="0">
                 <a:solidFill>
                   <a:srgbClr val="1B2B34"/>
                 </a:solidFill>
                 <a:latin typeface="Consolas"/>
               </a:rPr>
-              <a:t>      - 'OMP_NUM_THREADS={{threads}} ./stream'</a:t>
-            </a:r>
-          </a:p>
-          <a:p>
-            <a:pPr algn="l"/>
-            <a:r>
-              <a:rPr sz="1400" b="0">
+              <a:t>  inherits_from: base        # that's it — inherits everything</a:t>
+            </a:r>
+          </a:p>
+          <a:p>
+            <a:pPr algn="l"/>
+            <a:r>
+              <a:rPr sz="1250" b="0">
                 <a:solidFill>
                   <a:srgbClr val="1B2B34"/>
                 </a:solidFill>
@@ -7189,55 +7189,79 @@
           <a:p>
             <a:pPr algn="l"/>
             <a:r>
-              <a:rPr sz="1400" b="0">
+              <a:rPr sz="1250" b="0">
                 <a:solidFill>
                   <a:srgbClr val="1B2B34"/>
                 </a:solidFill>
                 <a:latin typeface="Consolas"/>
               </a:rPr>
-              <a:t>small:</a:t>
-            </a:r>
-          </a:p>
-          <a:p>
-            <a:pPr algn="l"/>
-            <a:r>
-              <a:rPr sz="1400" b="0">
+              <a:t>large:</a:t>
+            </a:r>
+          </a:p>
+          <a:p>
+            <a:pPr algn="l"/>
+            <a:r>
+              <a:rPr sz="1250" b="0">
                 <a:solidFill>
                   <a:srgbClr val="1B2B34"/>
                 </a:solidFill>
                 <a:latin typeface="Consolas"/>
               </a:rPr>
-              <a:t>  inherits_from: base          # that's it — inherits everything</a:t>
-            </a:r>
-          </a:p>
-          <a:p>
-            <a:pPr algn="l"/>
-            <a:r>
-              <a:rPr sz="1400" b="0">
+              <a:t>  inherits_from: base</a:t>
+            </a:r>
+          </a:p>
+          <a:p>
+            <a:pPr algn="l"/>
+            <a:r>
+              <a:rPr sz="1250" b="0">
                 <a:solidFill>
                   <a:srgbClr val="1B2B34"/>
                 </a:solidFill>
                 <a:latin typeface="Consolas"/>
               </a:rPr>
+              <a:t>  variables:</a:t>
+            </a:r>
+          </a:p>
+          <a:p>
+            <a:pPr algn="l"/>
+            <a:r>
+              <a:rPr sz="1250" b="0">
+                <a:solidFill>
+                  <a:srgbClr val="1B2B34"/>
+                </a:solidFill>
+                <a:latin typeface="Consolas"/>
+              </a:rPr>
+              <a:t>    threads: 5               # override just the variable</a:t>
+            </a:r>
+          </a:p>
+          <a:p>
+            <a:pPr algn="l"/>
+            <a:r>
+              <a:rPr sz="1250" b="0">
+                <a:solidFill>
+                  <a:srgbClr val="1B2B34"/>
+                </a:solidFill>
+                <a:latin typeface="Consolas"/>
+              </a:rPr>
               <a:t> </a:t>
             </a:r>
           </a:p>
           <a:p>
             <a:pPr algn="l"/>
             <a:r>
-              <a:rPr sz="1400" b="0">
+              <a:rPr sz="1250" b="0">
                 <a:solidFill>
                   <a:srgbClr val="1B2B34"/>
                 </a:solidFill>
                 <a:latin typeface="Consolas"/>
               </a:rPr>
-              <a:t>large:</a:t>
-            </a:r>
-          </a:p>
-          <a:p>
-            <a:pPr algn="l"/>
-            <a:r>
-              <a:rPr sz="1400" b="0">
+              <a:t>debug:</a:t>
+            </a:r>
+          </a:p>
+          <a:p>
+            <a:pPr algn="l"/>
+            <a:r>
+              <a:rPr sz="1250" b="0">
                 <a:solidFill>
                   <a:srgbClr val="1B2B34"/>
                 </a:solidFill>
@@ -7249,97 +7273,25 @@
           <a:p>
             <a:pPr algn="l"/>
             <a:r>
-              <a:rPr sz="1400" b="0">
+              <a:rPr sz="1250" b="0">
                 <a:solidFill>
                   <a:srgbClr val="1B2B34"/>
                 </a:solidFill>
                 <a:latin typeface="Consolas"/>
               </a:rPr>
-              <a:t>  variables:</a:t>
-            </a:r>
-          </a:p>
-          <a:p>
-            <a:pPr algn="l"/>
-            <a:r>
-              <a:rPr sz="1400" b="0">
+              <a:t>  build:                     # override just the build flags</a:t>
+            </a:r>
+          </a:p>
+          <a:p>
+            <a:pPr algn="l"/>
+            <a:r>
+              <a:rPr sz="1250" b="0">
                 <a:solidFill>
                   <a:srgbClr val="1B2B34"/>
                 </a:solidFill>
                 <a:latin typeface="Consolas"/>
               </a:rPr>
-              <a:t>    threads: 5                 # override just the variable</a:t>
-            </a:r>
-          </a:p>
-          <a:p>
-            <a:pPr algn="l"/>
-            <a:r>
-              <a:rPr sz="1400" b="0">
-                <a:solidFill>
-                  <a:srgbClr val="1B2B34"/>
-                </a:solidFill>
-                <a:latin typeface="Consolas"/>
-              </a:rPr>
-              <a:t> </a:t>
-            </a:r>
-          </a:p>
-          <a:p>
-            <a:pPr algn="l"/>
-            <a:r>
-              <a:rPr sz="1400" b="0">
-                <a:solidFill>
-                  <a:srgbClr val="1B2B34"/>
-                </a:solidFill>
-                <a:latin typeface="Consolas"/>
-              </a:rPr>
-              <a:t>debug:</a:t>
-            </a:r>
-          </a:p>
-          <a:p>
-            <a:pPr algn="l"/>
-            <a:r>
-              <a:rPr sz="1400" b="0">
-                <a:solidFill>
-                  <a:srgbClr val="1B2B34"/>
-                </a:solidFill>
-                <a:latin typeface="Consolas"/>
-              </a:rPr>
-              <a:t>  inherits_from: base</a:t>
-            </a:r>
-          </a:p>
-          <a:p>
-            <a:pPr algn="l"/>
-            <a:r>
-              <a:rPr sz="1400" b="0">
-                <a:solidFill>
-                  <a:srgbClr val="1B2B34"/>
-                </a:solidFill>
-                <a:latin typeface="Consolas"/>
-              </a:rPr>
-              <a:t>  build:</a:t>
-            </a:r>
-          </a:p>
-          <a:p>
-            <a:pPr algn="l"/>
-            <a:r>
-              <a:rPr sz="1400" b="0">
-                <a:solidFill>
-                  <a:srgbClr val="1B2B34"/>
-                </a:solidFill>
-                <a:latin typeface="Consolas"/>
-              </a:rPr>
-              <a:t>    cmds:</a:t>
-            </a:r>
-          </a:p>
-          <a:p>
-            <a:pPr algn="l"/>
-            <a:r>
-              <a:rPr sz="1400" b="0">
-                <a:solidFill>
-                  <a:srgbClr val="1B2B34"/>
-                </a:solidFill>
-                <a:latin typeface="Consolas"/>
-              </a:rPr>
-              <a:t>      - 'gcc -O3 -fopenmp -fsanitize=address stream.c -o stream'   # override the build</a:t>
+              <a:t>    cmds: ['gcc -O3 -fopenmp -fsanitize=address stream.c -o stream']</a:t>
             </a:r>
           </a:p>
         </p:txBody>

</xml_diff>

<commit_message>
Reorder: 'A fuller test' now follows the simple anatomy slide
Show the trivial example, then the fleshed-out one, before moving into
inheritance. New order: Anatomy -> A fuller test -> Inheritable defs ->
Inheritance in action.

Co-Authored-By: Claude Opus 4.8 (1M context) <noreply@anthropic.com>
</commit_message>
<xml_diff>
--- a/pavilion-workshop.pptx
+++ b/pavilion-workshop.pptx
@@ -620,7 +620,7 @@
           <a:lstStyle/>
           <a:p>
             <a:r>
-              <a:t>The fuller shape: a couple of variables up top (used below), the PBS scheduler targeting a queue, then the four stages — build (compile from source), run, result_parse (regex → triad_mbs), and result_evaluate (a pass/fail expression). Still just YAML.</a:t>
+              <a:t>One base owns the shared config and a variable (threads: 2). 'small' is literally just inherits_from: base — it takes everything. 'large' inherits and overrides only the variable (threads: 5). 'debug' inherits and overrides only the build, adding -fsanitize=address. Each child writes just its delta — that's the DRY win.</a:t>
             </a:r>
           </a:p>
         </p:txBody>
@@ -3070,7 +3070,7 @@
           <a:lstStyle/>
           <a:p>
             <a:r>
-              <a:t>Huge selling point. Real suites share tons of config (same build, same scheduler settings). Inheritance = write it once, variants override just the delta. Less code, less drift, one place to fix things.</a:t>
+              <a:t>The fuller shape: a couple of variables up top (used below), the PBS scheduler targeting a queue, then the four stages — build (compile from source), run, result_parse (regex → triad_mbs), and result_evaluate (a pass/fail expression). Still just YAML.</a:t>
             </a:r>
           </a:p>
         </p:txBody>
@@ -3140,7 +3140,7 @@
           <a:lstStyle/>
           <a:p>
             <a:r>
-              <a:t>One base owns the shared config and a variable (threads: 2). 'small' is literally just inherits_from: base — it takes everything. 'large' inherits and overrides only the variable (threads: 5). 'debug' inherits and overrides only the build, adding -fsanitize=address. Each child writes just its delta — that's the DRY win.</a:t>
+              <a:t>Huge selling point. Real suites share tons of config (same build, same scheduler settings). Inheritance = write it once, variants override just the delta. Less code, less drift, one place to fix things.</a:t>
             </a:r>
           </a:p>
         </p:txBody>
@@ -6716,7 +6716,7 @@
                 </a:solidFill>
                 <a:latin typeface="Arial"/>
               </a:rPr>
-              <a:t>A BIG ONE</a:t>
+              <a:t>CONCEPTS</a:t>
             </a:r>
           </a:p>
         </p:txBody>
@@ -6750,7 +6750,7 @@
                 </a:solidFill>
                 <a:latin typeface="Arial"/>
               </a:rPr>
-              <a:t>Inheritable test definitions</a:t>
+              <a:t>A fuller test (YAML)</a:t>
             </a:r>
           </a:p>
         </p:txBody>
@@ -6806,8 +6806,8 @@
         </p:nvSpPr>
         <p:spPr>
           <a:xfrm>
-            <a:off x="640080" y="1691640"/>
-            <a:ext cx="10972800" cy="4754880"/>
+            <a:off x="640080" y="1600200"/>
+            <a:ext cx="10972800" cy="457200"/>
           </a:xfrm>
           <a:prstGeom prst="rect">
             <a:avLst/>
@@ -6820,67 +6820,308 @@
           </a:bodyPr>
           <a:lstStyle/>
           <a:p>
-            <a:pPr>
-              <a:spcAft>
-                <a:spcPts val="1000"/>
-              </a:spcAft>
-            </a:pPr>
-            <a:r>
-              <a:rPr sz="2000" b="0">
-                <a:solidFill>
-                  <a:srgbClr val="21252B"/>
-                </a:solidFill>
-                <a:latin typeface="Arial"/>
-              </a:rPr>
-              <a:t>•  Write shared config once in a base test — scheduler, build, run, parsing.</a:t>
-            </a:r>
-          </a:p>
-          <a:p>
-            <a:pPr>
-              <a:spcAft>
-                <a:spcPts val="1000"/>
-              </a:spcAft>
-            </a:pPr>
-            <a:r>
-              <a:rPr sz="2000" b="0">
-                <a:solidFill>
-                  <a:srgbClr val="21252B"/>
-                </a:solidFill>
-                <a:latin typeface="Arial"/>
-              </a:rPr>
-              <a:t>•  Other tests just say  inherits_from: &lt;base&gt;  and get all of it for free.</a:t>
-            </a:r>
-          </a:p>
-          <a:p>
-            <a:pPr>
-              <a:spcAft>
-                <a:spcPts val="1000"/>
-              </a:spcAft>
-            </a:pPr>
-            <a:r>
-              <a:rPr sz="2000" b="0">
-                <a:solidFill>
-                  <a:srgbClr val="21252B"/>
-                </a:solidFill>
-                <a:latin typeface="Arial"/>
-              </a:rPr>
-              <a:t>•  Each one overrides only what changes — no copy-paste, no drift.</a:t>
-            </a:r>
-          </a:p>
-          <a:p>
-            <a:pPr>
-              <a:spcAft>
-                <a:spcPts val="1000"/>
-              </a:spcAft>
-            </a:pPr>
-            <a:r>
-              <a:rPr sz="2000" b="0">
-                <a:solidFill>
-                  <a:srgbClr val="21252B"/>
-                </a:solidFill>
-                <a:latin typeface="Arial"/>
-              </a:rPr>
-              <a:t>•  Fix the base once → every test that inherits it updates.</a:t>
+            <a:r>
+              <a:rPr sz="1600" b="0">
+                <a:solidFill>
+                  <a:srgbClr val="5B6674"/>
+                </a:solidFill>
+                <a:latin typeface="Arial"/>
+              </a:rPr>
+              <a:t>Same shape, more of it — variables, PBS + a queue, and build → run → parse → evaluate.</a:t>
+            </a:r>
+          </a:p>
+        </p:txBody>
+      </p:sp>
+      <p:sp>
+        <p:nvSpPr>
+          <p:cNvPr id="6" name="Rectangle 5"/>
+          <p:cNvSpPr/>
+          <p:nvPr/>
+        </p:nvSpPr>
+        <p:spPr>
+          <a:xfrm>
+            <a:off x="640080" y="2148840"/>
+            <a:ext cx="10972800" cy="4572000"/>
+          </a:xfrm>
+          <a:prstGeom prst="rect">
+            <a:avLst/>
+          </a:prstGeom>
+          <a:solidFill>
+            <a:srgbClr val="F3F4F6"/>
+          </a:solidFill>
+          <a:ln w="12700">
+            <a:solidFill>
+              <a:srgbClr val="D5DAE0"/>
+            </a:solidFill>
+          </a:ln>
+        </p:spPr>
+        <p:style>
+          <a:lnRef idx="1">
+            <a:schemeClr val="accent1"/>
+          </a:lnRef>
+          <a:fillRef idx="3">
+            <a:schemeClr val="accent1"/>
+          </a:fillRef>
+          <a:effectRef idx="2">
+            <a:schemeClr val="accent1"/>
+          </a:effectRef>
+          <a:fontRef idx="minor">
+            <a:schemeClr val="lt1"/>
+          </a:fontRef>
+        </p:style>
+        <p:txBody>
+          <a:bodyPr rtlCol="0" anchor="t" wrap="square" lIns="228600" tIns="164592"/>
+          <a:lstStyle/>
+          <a:p>
+            <a:pPr algn="l"/>
+            <a:r>
+              <a:rPr sz="1350" b="0">
+                <a:solidFill>
+                  <a:srgbClr val="1B2B34"/>
+                </a:solidFill>
+                <a:latin typeface="Consolas"/>
+              </a:rPr>
+              <a:t>stream:</a:t>
+            </a:r>
+          </a:p>
+          <a:p>
+            <a:pPr algn="l"/>
+            <a:r>
+              <a:rPr sz="1350" b="0">
+                <a:solidFill>
+                  <a:srgbClr val="1B2B34"/>
+                </a:solidFill>
+                <a:latin typeface="Consolas"/>
+              </a:rPr>
+              <a:t>  variables:</a:t>
+            </a:r>
+          </a:p>
+          <a:p>
+            <a:pPr algn="l"/>
+            <a:r>
+              <a:rPr sz="1350" b="0">
+                <a:solidFill>
+                  <a:srgbClr val="1B2B34"/>
+                </a:solidFill>
+                <a:latin typeface="Consolas"/>
+              </a:rPr>
+              <a:t>    array_size: 40000000</a:t>
+            </a:r>
+          </a:p>
+          <a:p>
+            <a:pPr algn="l"/>
+            <a:r>
+              <a:rPr sz="1350" b="0">
+                <a:solidFill>
+                  <a:srgbClr val="1B2B34"/>
+                </a:solidFill>
+                <a:latin typeface="Consolas"/>
+              </a:rPr>
+              <a:t>    threads: 4</a:t>
+            </a:r>
+          </a:p>
+          <a:p>
+            <a:pPr algn="l"/>
+            <a:r>
+              <a:rPr sz="1350" b="0">
+                <a:solidFill>
+                  <a:srgbClr val="1B2B34"/>
+                </a:solidFill>
+                <a:latin typeface="Consolas"/>
+              </a:rPr>
+              <a:t>  scheduler: pbs</a:t>
+            </a:r>
+          </a:p>
+          <a:p>
+            <a:pPr algn="l"/>
+            <a:r>
+              <a:rPr sz="1350" b="0">
+                <a:solidFill>
+                  <a:srgbClr val="1B2B34"/>
+                </a:solidFill>
+                <a:latin typeface="Consolas"/>
+              </a:rPr>
+              <a:t>  schedule:</a:t>
+            </a:r>
+          </a:p>
+          <a:p>
+            <a:pPr algn="l"/>
+            <a:r>
+              <a:rPr sz="1350" b="0">
+                <a:solidFill>
+                  <a:srgbClr val="1B2B34"/>
+                </a:solidFill>
+                <a:latin typeface="Consolas"/>
+              </a:rPr>
+              <a:t>    pbs:</a:t>
+            </a:r>
+          </a:p>
+          <a:p>
+            <a:pPr algn="l"/>
+            <a:r>
+              <a:rPr sz="1350" b="0">
+                <a:solidFill>
+                  <a:srgbClr val="1B2B34"/>
+                </a:solidFill>
+                <a:latin typeface="Consolas"/>
+              </a:rPr>
+              <a:t>      queue: workq          # target a queue</a:t>
+            </a:r>
+          </a:p>
+          <a:p>
+            <a:pPr algn="l"/>
+            <a:r>
+              <a:rPr sz="1350" b="0">
+                <a:solidFill>
+                  <a:srgbClr val="1B2B34"/>
+                </a:solidFill>
+                <a:latin typeface="Consolas"/>
+              </a:rPr>
+              <a:t>      nodes: 1</a:t>
+            </a:r>
+          </a:p>
+          <a:p>
+            <a:pPr algn="l"/>
+            <a:r>
+              <a:rPr sz="1350" b="0">
+                <a:solidFill>
+                  <a:srgbClr val="1B2B34"/>
+                </a:solidFill>
+                <a:latin typeface="Consolas"/>
+              </a:rPr>
+              <a:t>      walltime: '00:05:00'</a:t>
+            </a:r>
+          </a:p>
+          <a:p>
+            <a:pPr algn="l"/>
+            <a:r>
+              <a:rPr sz="1350" b="0">
+                <a:solidFill>
+                  <a:srgbClr val="1B2B34"/>
+                </a:solidFill>
+                <a:latin typeface="Consolas"/>
+              </a:rPr>
+              <a:t>  build:                    # compile from source</a:t>
+            </a:r>
+          </a:p>
+          <a:p>
+            <a:pPr algn="l"/>
+            <a:r>
+              <a:rPr sz="1350" b="0">
+                <a:solidFill>
+                  <a:srgbClr val="1B2B34"/>
+                </a:solidFill>
+                <a:latin typeface="Consolas"/>
+              </a:rPr>
+              <a:t>    source_path: stream.c</a:t>
+            </a:r>
+          </a:p>
+          <a:p>
+            <a:pPr algn="l"/>
+            <a:r>
+              <a:rPr sz="1350" b="0">
+                <a:solidFill>
+                  <a:srgbClr val="1B2B34"/>
+                </a:solidFill>
+                <a:latin typeface="Consolas"/>
+              </a:rPr>
+              <a:t>    cmds: ['gcc -fopenmp -DN={{array_size}} stream.c -o stream']</a:t>
+            </a:r>
+          </a:p>
+          <a:p>
+            <a:pPr algn="l"/>
+            <a:r>
+              <a:rPr sz="1350" b="0">
+                <a:solidFill>
+                  <a:srgbClr val="1B2B34"/>
+                </a:solidFill>
+                <a:latin typeface="Consolas"/>
+              </a:rPr>
+              <a:t>  run:</a:t>
+            </a:r>
+          </a:p>
+          <a:p>
+            <a:pPr algn="l"/>
+            <a:r>
+              <a:rPr sz="1350" b="0">
+                <a:solidFill>
+                  <a:srgbClr val="1B2B34"/>
+                </a:solidFill>
+                <a:latin typeface="Consolas"/>
+              </a:rPr>
+              <a:t>    env: {OMP_NUM_THREADS: '{{threads}}'}</a:t>
+            </a:r>
+          </a:p>
+          <a:p>
+            <a:pPr algn="l"/>
+            <a:r>
+              <a:rPr sz="1350" b="0">
+                <a:solidFill>
+                  <a:srgbClr val="1B2B34"/>
+                </a:solidFill>
+                <a:latin typeface="Consolas"/>
+              </a:rPr>
+              <a:t>    cmds: ['./stream']</a:t>
+            </a:r>
+          </a:p>
+          <a:p>
+            <a:pPr algn="l"/>
+            <a:r>
+              <a:rPr sz="1350" b="0">
+                <a:solidFill>
+                  <a:srgbClr val="1B2B34"/>
+                </a:solidFill>
+                <a:latin typeface="Consolas"/>
+              </a:rPr>
+              <a:t>  result_parse:</a:t>
+            </a:r>
+          </a:p>
+          <a:p>
+            <a:pPr algn="l"/>
+            <a:r>
+              <a:rPr sz="1350" b="0">
+                <a:solidFill>
+                  <a:srgbClr val="1B2B34"/>
+                </a:solidFill>
+                <a:latin typeface="Consolas"/>
+              </a:rPr>
+              <a:t>    regex:</a:t>
+            </a:r>
+          </a:p>
+          <a:p>
+            <a:pPr algn="l"/>
+            <a:r>
+              <a:rPr sz="1350" b="0">
+                <a:solidFill>
+                  <a:srgbClr val="1B2B34"/>
+                </a:solidFill>
+                <a:latin typeface="Consolas"/>
+              </a:rPr>
+              <a:t>      triad_mbs: {regex: 'Triad:\s+(\S+)'}</a:t>
+            </a:r>
+          </a:p>
+          <a:p>
+            <a:pPr algn="l"/>
+            <a:r>
+              <a:rPr sz="1350" b="0">
+                <a:solidFill>
+                  <a:srgbClr val="1B2B34"/>
+                </a:solidFill>
+                <a:latin typeface="Consolas"/>
+              </a:rPr>
+              <a:t>  result_evaluate:</a:t>
+            </a:r>
+          </a:p>
+          <a:p>
+            <a:pPr algn="l"/>
+            <a:r>
+              <a:rPr sz="1350" b="0">
+                <a:solidFill>
+                  <a:srgbClr val="1B2B34"/>
+                </a:solidFill>
+                <a:latin typeface="Consolas"/>
+              </a:rPr>
+              <a:t>    result: 'triad_mbs &gt; 10000'    # PASS only if fast enough</a:t>
             </a:r>
           </a:p>
         </p:txBody>
@@ -6966,7 +7207,7 @@
                 </a:solidFill>
                 <a:latin typeface="Arial"/>
               </a:rPr>
-              <a:t>Inheritance in action</a:t>
+              <a:t>Inheritable test definitions</a:t>
             </a:r>
           </a:p>
         </p:txBody>
@@ -7016,282 +7257,87 @@
       </p:sp>
       <p:sp>
         <p:nvSpPr>
-          <p:cNvPr id="5" name="Rectangle 4"/>
-          <p:cNvSpPr/>
-          <p:nvPr/>
-        </p:nvSpPr>
-        <p:spPr>
-          <a:xfrm>
-            <a:off x="640080" y="1783080"/>
-            <a:ext cx="10972800" cy="4983480"/>
-          </a:xfrm>
-          <a:prstGeom prst="rect">
-            <a:avLst/>
-          </a:prstGeom>
-          <a:solidFill>
-            <a:srgbClr val="F3F4F6"/>
-          </a:solidFill>
-          <a:ln w="12700">
-            <a:solidFill>
-              <a:srgbClr val="D5DAE0"/>
-            </a:solidFill>
-          </a:ln>
-        </p:spPr>
-        <p:style>
-          <a:lnRef idx="1">
-            <a:schemeClr val="accent1"/>
-          </a:lnRef>
-          <a:fillRef idx="3">
-            <a:schemeClr val="accent1"/>
-          </a:fillRef>
-          <a:effectRef idx="2">
-            <a:schemeClr val="accent1"/>
-          </a:effectRef>
-          <a:fontRef idx="minor">
-            <a:schemeClr val="lt1"/>
-          </a:fontRef>
-        </p:style>
-        <p:txBody>
-          <a:bodyPr rtlCol="0" anchor="t" wrap="square" lIns="228600" tIns="164592"/>
-          <a:lstStyle/>
-          <a:p>
-            <a:pPr algn="l"/>
-            <a:r>
-              <a:rPr sz="1250" b="0">
-                <a:solidFill>
-                  <a:srgbClr val="1B2B34"/>
-                </a:solidFill>
-                <a:latin typeface="Consolas"/>
-              </a:rPr>
-              <a:t>base:                        # shared config, written once</a:t>
-            </a:r>
-          </a:p>
-          <a:p>
-            <a:pPr algn="l"/>
-            <a:r>
-              <a:rPr sz="1250" b="0">
-                <a:solidFill>
-                  <a:srgbClr val="1B2B34"/>
-                </a:solidFill>
-                <a:latin typeface="Consolas"/>
-              </a:rPr>
-              <a:t>  variables:</a:t>
-            </a:r>
-          </a:p>
-          <a:p>
-            <a:pPr algn="l"/>
-            <a:r>
-              <a:rPr sz="1250" b="0">
-                <a:solidFill>
-                  <a:srgbClr val="1B2B34"/>
-                </a:solidFill>
-                <a:latin typeface="Consolas"/>
-              </a:rPr>
-              <a:t>    threads: 2</a:t>
-            </a:r>
-          </a:p>
-          <a:p>
-            <a:pPr algn="l"/>
-            <a:r>
-              <a:rPr sz="1250" b="0">
-                <a:solidFill>
-                  <a:srgbClr val="1B2B34"/>
-                </a:solidFill>
-                <a:latin typeface="Consolas"/>
-              </a:rPr>
-              <a:t>  build:</a:t>
-            </a:r>
-          </a:p>
-          <a:p>
-            <a:pPr algn="l"/>
-            <a:r>
-              <a:rPr sz="1250" b="0">
-                <a:solidFill>
-                  <a:srgbClr val="1B2B34"/>
-                </a:solidFill>
-                <a:latin typeface="Consolas"/>
-              </a:rPr>
-              <a:t>    cmds: ['gcc -O3 -fopenmp stream.c -o stream']</a:t>
-            </a:r>
-          </a:p>
-          <a:p>
-            <a:pPr algn="l"/>
-            <a:r>
-              <a:rPr sz="1250" b="0">
-                <a:solidFill>
-                  <a:srgbClr val="1B2B34"/>
-                </a:solidFill>
-                <a:latin typeface="Consolas"/>
-              </a:rPr>
-              <a:t>  run:</a:t>
-            </a:r>
-          </a:p>
-          <a:p>
-            <a:pPr algn="l"/>
-            <a:r>
-              <a:rPr sz="1250" b="0">
-                <a:solidFill>
-                  <a:srgbClr val="1B2B34"/>
-                </a:solidFill>
-                <a:latin typeface="Consolas"/>
-              </a:rPr>
-              <a:t>    cmds: ['OMP_NUM_THREADS={{threads}} ./stream']</a:t>
-            </a:r>
-          </a:p>
-          <a:p>
-            <a:pPr algn="l"/>
-            <a:r>
-              <a:rPr sz="1250" b="0">
-                <a:solidFill>
-                  <a:srgbClr val="1B2B34"/>
-                </a:solidFill>
-                <a:latin typeface="Consolas"/>
-              </a:rPr>
-              <a:t> </a:t>
-            </a:r>
-          </a:p>
-          <a:p>
-            <a:pPr algn="l"/>
-            <a:r>
-              <a:rPr sz="1250" b="0">
-                <a:solidFill>
-                  <a:srgbClr val="1B2B34"/>
-                </a:solidFill>
-                <a:latin typeface="Consolas"/>
-              </a:rPr>
-              <a:t>small:</a:t>
-            </a:r>
-          </a:p>
-          <a:p>
-            <a:pPr algn="l"/>
-            <a:r>
-              <a:rPr sz="1250" b="0">
-                <a:solidFill>
-                  <a:srgbClr val="1B2B34"/>
-                </a:solidFill>
-                <a:latin typeface="Consolas"/>
-              </a:rPr>
-              <a:t>  inherits_from: base        # that's it — inherits everything</a:t>
-            </a:r>
-          </a:p>
-          <a:p>
-            <a:pPr algn="l"/>
-            <a:r>
-              <a:rPr sz="1250" b="0">
-                <a:solidFill>
-                  <a:srgbClr val="1B2B34"/>
-                </a:solidFill>
-                <a:latin typeface="Consolas"/>
-              </a:rPr>
-              <a:t> </a:t>
-            </a:r>
-          </a:p>
-          <a:p>
-            <a:pPr algn="l"/>
-            <a:r>
-              <a:rPr sz="1250" b="0">
-                <a:solidFill>
-                  <a:srgbClr val="1B2B34"/>
-                </a:solidFill>
-                <a:latin typeface="Consolas"/>
-              </a:rPr>
-              <a:t>large:</a:t>
-            </a:r>
-          </a:p>
-          <a:p>
-            <a:pPr algn="l"/>
-            <a:r>
-              <a:rPr sz="1250" b="0">
-                <a:solidFill>
-                  <a:srgbClr val="1B2B34"/>
-                </a:solidFill>
-                <a:latin typeface="Consolas"/>
-              </a:rPr>
-              <a:t>  inherits_from: base</a:t>
-            </a:r>
-          </a:p>
-          <a:p>
-            <a:pPr algn="l"/>
-            <a:r>
-              <a:rPr sz="1250" b="0">
-                <a:solidFill>
-                  <a:srgbClr val="1B2B34"/>
-                </a:solidFill>
-                <a:latin typeface="Consolas"/>
-              </a:rPr>
-              <a:t>  variables:</a:t>
-            </a:r>
-          </a:p>
-          <a:p>
-            <a:pPr algn="l"/>
-            <a:r>
-              <a:rPr sz="1250" b="0">
-                <a:solidFill>
-                  <a:srgbClr val="1B2B34"/>
-                </a:solidFill>
-                <a:latin typeface="Consolas"/>
-              </a:rPr>
-              <a:t>    threads: 5               # override just the variable</a:t>
-            </a:r>
-          </a:p>
-          <a:p>
-            <a:pPr algn="l"/>
-            <a:r>
-              <a:rPr sz="1250" b="0">
-                <a:solidFill>
-                  <a:srgbClr val="1B2B34"/>
-                </a:solidFill>
-                <a:latin typeface="Consolas"/>
-              </a:rPr>
-              <a:t> </a:t>
-            </a:r>
-          </a:p>
-          <a:p>
-            <a:pPr algn="l"/>
-            <a:r>
-              <a:rPr sz="1250" b="0">
-                <a:solidFill>
-                  <a:srgbClr val="1B2B34"/>
-                </a:solidFill>
-                <a:latin typeface="Consolas"/>
-              </a:rPr>
-              <a:t>debug:</a:t>
-            </a:r>
-          </a:p>
-          <a:p>
-            <a:pPr algn="l"/>
-            <a:r>
-              <a:rPr sz="1250" b="0">
-                <a:solidFill>
-                  <a:srgbClr val="1B2B34"/>
-                </a:solidFill>
-                <a:latin typeface="Consolas"/>
-              </a:rPr>
-              <a:t>  inherits_from: base</a:t>
-            </a:r>
-          </a:p>
-          <a:p>
-            <a:pPr algn="l"/>
-            <a:r>
-              <a:rPr sz="1250" b="0">
-                <a:solidFill>
-                  <a:srgbClr val="1B2B34"/>
-                </a:solidFill>
-                <a:latin typeface="Consolas"/>
-              </a:rPr>
-              <a:t>  build:                     # override just the build flags</a:t>
-            </a:r>
-          </a:p>
-          <a:p>
-            <a:pPr algn="l"/>
-            <a:r>
-              <a:rPr sz="1250" b="0">
-                <a:solidFill>
-                  <a:srgbClr val="1B2B34"/>
-                </a:solidFill>
-                <a:latin typeface="Consolas"/>
-              </a:rPr>
-              <a:t>    cmds: ['gcc -O3 -fopenmp -fsanitize=address stream.c -o stream']</a:t>
+          <p:cNvPr id="5" name="TextBox 4"/>
+          <p:cNvSpPr txBox="1"/>
+          <p:nvPr/>
+        </p:nvSpPr>
+        <p:spPr>
+          <a:xfrm>
+            <a:off x="640080" y="1691640"/>
+            <a:ext cx="10972800" cy="4754880"/>
+          </a:xfrm>
+          <a:prstGeom prst="rect">
+            <a:avLst/>
+          </a:prstGeom>
+          <a:noFill/>
+        </p:spPr>
+        <p:txBody>
+          <a:bodyPr wrap="square">
+            <a:spAutoFit/>
+          </a:bodyPr>
+          <a:lstStyle/>
+          <a:p>
+            <a:pPr>
+              <a:spcAft>
+                <a:spcPts val="1000"/>
+              </a:spcAft>
+            </a:pPr>
+            <a:r>
+              <a:rPr sz="2000" b="0">
+                <a:solidFill>
+                  <a:srgbClr val="21252B"/>
+                </a:solidFill>
+                <a:latin typeface="Arial"/>
+              </a:rPr>
+              <a:t>•  Write shared config once in a base test — scheduler, build, run, parsing.</a:t>
+            </a:r>
+          </a:p>
+          <a:p>
+            <a:pPr>
+              <a:spcAft>
+                <a:spcPts val="1000"/>
+              </a:spcAft>
+            </a:pPr>
+            <a:r>
+              <a:rPr sz="2000" b="0">
+                <a:solidFill>
+                  <a:srgbClr val="21252B"/>
+                </a:solidFill>
+                <a:latin typeface="Arial"/>
+              </a:rPr>
+              <a:t>•  Other tests just say  inherits_from: &lt;base&gt;  and get all of it for free.</a:t>
+            </a:r>
+          </a:p>
+          <a:p>
+            <a:pPr>
+              <a:spcAft>
+                <a:spcPts val="1000"/>
+              </a:spcAft>
+            </a:pPr>
+            <a:r>
+              <a:rPr sz="2000" b="0">
+                <a:solidFill>
+                  <a:srgbClr val="21252B"/>
+                </a:solidFill>
+                <a:latin typeface="Arial"/>
+              </a:rPr>
+              <a:t>•  Each one overrides only what changes — no copy-paste, no drift.</a:t>
+            </a:r>
+          </a:p>
+          <a:p>
+            <a:pPr>
+              <a:spcAft>
+                <a:spcPts val="1000"/>
+              </a:spcAft>
+            </a:pPr>
+            <a:r>
+              <a:rPr sz="2000" b="0">
+                <a:solidFill>
+                  <a:srgbClr val="21252B"/>
+                </a:solidFill>
+                <a:latin typeface="Arial"/>
+              </a:rPr>
+              <a:t>•  Fix the base once → every test that inherits it updates.</a:t>
             </a:r>
           </a:p>
         </p:txBody>
@@ -7343,7 +7389,7 @@
                 </a:solidFill>
                 <a:latin typeface="Arial"/>
               </a:rPr>
-              <a:t>CONCEPTS</a:t>
+              <a:t>A BIG ONE</a:t>
             </a:r>
           </a:p>
         </p:txBody>
@@ -7377,7 +7423,7 @@
                 </a:solidFill>
                 <a:latin typeface="Arial"/>
               </a:rPr>
-              <a:t>A fuller test (YAML)</a:t>
+              <a:t>Inheritance in action</a:t>
             </a:r>
           </a:p>
         </p:txBody>
@@ -7427,48 +7473,14 @@
       </p:sp>
       <p:sp>
         <p:nvSpPr>
-          <p:cNvPr id="5" name="TextBox 4"/>
-          <p:cNvSpPr txBox="1"/>
-          <p:nvPr/>
-        </p:nvSpPr>
-        <p:spPr>
-          <a:xfrm>
-            <a:off x="640080" y="1600200"/>
-            <a:ext cx="10972800" cy="457200"/>
-          </a:xfrm>
-          <a:prstGeom prst="rect">
-            <a:avLst/>
-          </a:prstGeom>
-          <a:noFill/>
-        </p:spPr>
-        <p:txBody>
-          <a:bodyPr wrap="square">
-            <a:spAutoFit/>
-          </a:bodyPr>
-          <a:lstStyle/>
-          <a:p>
-            <a:r>
-              <a:rPr sz="1600" b="0">
-                <a:solidFill>
-                  <a:srgbClr val="5B6674"/>
-                </a:solidFill>
-                <a:latin typeface="Arial"/>
-              </a:rPr>
-              <a:t>Same shape, more of it — variables, PBS + a queue, and build → run → parse → evaluate.</a:t>
-            </a:r>
-          </a:p>
-        </p:txBody>
-      </p:sp>
-      <p:sp>
-        <p:nvSpPr>
-          <p:cNvPr id="6" name="Rectangle 5"/>
+          <p:cNvPr id="5" name="Rectangle 4"/>
           <p:cNvSpPr/>
           <p:nvPr/>
         </p:nvSpPr>
         <p:spPr>
           <a:xfrm>
-            <a:off x="640080" y="2148840"/>
-            <a:ext cx="10972800" cy="4572000"/>
+            <a:off x="640080" y="1783080"/>
+            <a:ext cx="10972800" cy="4983480"/>
           </a:xfrm>
           <a:prstGeom prst="rect">
             <a:avLst/>
@@ -7502,19 +7514,19 @@
           <a:p>
             <a:pPr algn="l"/>
             <a:r>
-              <a:rPr sz="1350" b="0">
+              <a:rPr sz="1250" b="0">
                 <a:solidFill>
                   <a:srgbClr val="1B2B34"/>
                 </a:solidFill>
                 <a:latin typeface="Consolas"/>
               </a:rPr>
-              <a:t>stream:</a:t>
-            </a:r>
-          </a:p>
-          <a:p>
-            <a:pPr algn="l"/>
-            <a:r>
-              <a:rPr sz="1350" b="0">
+              <a:t>base:                        # shared config, written once</a:t>
+            </a:r>
+          </a:p>
+          <a:p>
+            <a:pPr algn="l"/>
+            <a:r>
+              <a:rPr sz="1250" b="0">
                 <a:solidFill>
                   <a:srgbClr val="1B2B34"/>
                 </a:solidFill>
@@ -7526,229 +7538,217 @@
           <a:p>
             <a:pPr algn="l"/>
             <a:r>
-              <a:rPr sz="1350" b="0">
+              <a:rPr sz="1250" b="0">
                 <a:solidFill>
                   <a:srgbClr val="1B2B34"/>
                 </a:solidFill>
                 <a:latin typeface="Consolas"/>
               </a:rPr>
-              <a:t>    array_size: 40000000</a:t>
-            </a:r>
-          </a:p>
-          <a:p>
-            <a:pPr algn="l"/>
-            <a:r>
-              <a:rPr sz="1350" b="0">
+              <a:t>    threads: 2</a:t>
+            </a:r>
+          </a:p>
+          <a:p>
+            <a:pPr algn="l"/>
+            <a:r>
+              <a:rPr sz="1250" b="0">
                 <a:solidFill>
                   <a:srgbClr val="1B2B34"/>
                 </a:solidFill>
                 <a:latin typeface="Consolas"/>
               </a:rPr>
-              <a:t>    threads: 4</a:t>
-            </a:r>
-          </a:p>
-          <a:p>
-            <a:pPr algn="l"/>
-            <a:r>
-              <a:rPr sz="1350" b="0">
+              <a:t>  build:</a:t>
+            </a:r>
+          </a:p>
+          <a:p>
+            <a:pPr algn="l"/>
+            <a:r>
+              <a:rPr sz="1250" b="0">
                 <a:solidFill>
                   <a:srgbClr val="1B2B34"/>
                 </a:solidFill>
                 <a:latin typeface="Consolas"/>
               </a:rPr>
-              <a:t>  scheduler: pbs</a:t>
-            </a:r>
-          </a:p>
-          <a:p>
-            <a:pPr algn="l"/>
-            <a:r>
-              <a:rPr sz="1350" b="0">
+              <a:t>    cmds: ['gcc -O3 -fopenmp stream.c -o stream']</a:t>
+            </a:r>
+          </a:p>
+          <a:p>
+            <a:pPr algn="l"/>
+            <a:r>
+              <a:rPr sz="1250" b="0">
                 <a:solidFill>
                   <a:srgbClr val="1B2B34"/>
                 </a:solidFill>
                 <a:latin typeface="Consolas"/>
               </a:rPr>
-              <a:t>  schedule:</a:t>
-            </a:r>
-          </a:p>
-          <a:p>
-            <a:pPr algn="l"/>
-            <a:r>
-              <a:rPr sz="1350" b="0">
+              <a:t>  run:</a:t>
+            </a:r>
+          </a:p>
+          <a:p>
+            <a:pPr algn="l"/>
+            <a:r>
+              <a:rPr sz="1250" b="0">
                 <a:solidFill>
                   <a:srgbClr val="1B2B34"/>
                 </a:solidFill>
                 <a:latin typeface="Consolas"/>
               </a:rPr>
-              <a:t>    pbs:</a:t>
-            </a:r>
-          </a:p>
-          <a:p>
-            <a:pPr algn="l"/>
-            <a:r>
-              <a:rPr sz="1350" b="0">
+              <a:t>    cmds: ['OMP_NUM_THREADS={{threads}} ./stream']</a:t>
+            </a:r>
+          </a:p>
+          <a:p>
+            <a:pPr algn="l"/>
+            <a:r>
+              <a:rPr sz="1250" b="0">
                 <a:solidFill>
                   <a:srgbClr val="1B2B34"/>
                 </a:solidFill>
                 <a:latin typeface="Consolas"/>
               </a:rPr>
-              <a:t>      queue: workq          # target a queue</a:t>
-            </a:r>
-          </a:p>
-          <a:p>
-            <a:pPr algn="l"/>
-            <a:r>
-              <a:rPr sz="1350" b="0">
+              <a:t> </a:t>
+            </a:r>
+          </a:p>
+          <a:p>
+            <a:pPr algn="l"/>
+            <a:r>
+              <a:rPr sz="1250" b="0">
                 <a:solidFill>
                   <a:srgbClr val="1B2B34"/>
                 </a:solidFill>
                 <a:latin typeface="Consolas"/>
               </a:rPr>
-              <a:t>      nodes: 1</a:t>
-            </a:r>
-          </a:p>
-          <a:p>
-            <a:pPr algn="l"/>
-            <a:r>
-              <a:rPr sz="1350" b="0">
+              <a:t>small:</a:t>
+            </a:r>
+          </a:p>
+          <a:p>
+            <a:pPr algn="l"/>
+            <a:r>
+              <a:rPr sz="1250" b="0">
                 <a:solidFill>
                   <a:srgbClr val="1B2B34"/>
                 </a:solidFill>
                 <a:latin typeface="Consolas"/>
               </a:rPr>
-              <a:t>      walltime: '00:05:00'</a:t>
-            </a:r>
-          </a:p>
-          <a:p>
-            <a:pPr algn="l"/>
-            <a:r>
-              <a:rPr sz="1350" b="0">
+              <a:t>  inherits_from: base        # that's it — inherits everything</a:t>
+            </a:r>
+          </a:p>
+          <a:p>
+            <a:pPr algn="l"/>
+            <a:r>
+              <a:rPr sz="1250" b="0">
                 <a:solidFill>
                   <a:srgbClr val="1B2B34"/>
                 </a:solidFill>
                 <a:latin typeface="Consolas"/>
               </a:rPr>
-              <a:t>  build:                    # compile from source</a:t>
-            </a:r>
-          </a:p>
-          <a:p>
-            <a:pPr algn="l"/>
-            <a:r>
-              <a:rPr sz="1350" b="0">
+              <a:t> </a:t>
+            </a:r>
+          </a:p>
+          <a:p>
+            <a:pPr algn="l"/>
+            <a:r>
+              <a:rPr sz="1250" b="0">
                 <a:solidFill>
                   <a:srgbClr val="1B2B34"/>
                 </a:solidFill>
                 <a:latin typeface="Consolas"/>
               </a:rPr>
-              <a:t>    source_path: stream.c</a:t>
-            </a:r>
-          </a:p>
-          <a:p>
-            <a:pPr algn="l"/>
-            <a:r>
-              <a:rPr sz="1350" b="0">
+              <a:t>large:</a:t>
+            </a:r>
+          </a:p>
+          <a:p>
+            <a:pPr algn="l"/>
+            <a:r>
+              <a:rPr sz="1250" b="0">
                 <a:solidFill>
                   <a:srgbClr val="1B2B34"/>
                 </a:solidFill>
                 <a:latin typeface="Consolas"/>
               </a:rPr>
-              <a:t>    cmds: ['gcc -fopenmp -DN={{array_size}} stream.c -o stream']</a:t>
-            </a:r>
-          </a:p>
-          <a:p>
-            <a:pPr algn="l"/>
-            <a:r>
-              <a:rPr sz="1350" b="0">
+              <a:t>  inherits_from: base</a:t>
+            </a:r>
+          </a:p>
+          <a:p>
+            <a:pPr algn="l"/>
+            <a:r>
+              <a:rPr sz="1250" b="0">
                 <a:solidFill>
                   <a:srgbClr val="1B2B34"/>
                 </a:solidFill>
                 <a:latin typeface="Consolas"/>
               </a:rPr>
-              <a:t>  run:</a:t>
-            </a:r>
-          </a:p>
-          <a:p>
-            <a:pPr algn="l"/>
-            <a:r>
-              <a:rPr sz="1350" b="0">
+              <a:t>  variables:</a:t>
+            </a:r>
+          </a:p>
+          <a:p>
+            <a:pPr algn="l"/>
+            <a:r>
+              <a:rPr sz="1250" b="0">
                 <a:solidFill>
                   <a:srgbClr val="1B2B34"/>
                 </a:solidFill>
                 <a:latin typeface="Consolas"/>
               </a:rPr>
-              <a:t>    env: {OMP_NUM_THREADS: '{{threads}}'}</a:t>
-            </a:r>
-          </a:p>
-          <a:p>
-            <a:pPr algn="l"/>
-            <a:r>
-              <a:rPr sz="1350" b="0">
+              <a:t>    threads: 5               # override just the variable</a:t>
+            </a:r>
+          </a:p>
+          <a:p>
+            <a:pPr algn="l"/>
+            <a:r>
+              <a:rPr sz="1250" b="0">
                 <a:solidFill>
                   <a:srgbClr val="1B2B34"/>
                 </a:solidFill>
                 <a:latin typeface="Consolas"/>
               </a:rPr>
-              <a:t>    cmds: ['./stream']</a:t>
-            </a:r>
-          </a:p>
-          <a:p>
-            <a:pPr algn="l"/>
-            <a:r>
-              <a:rPr sz="1350" b="0">
+              <a:t> </a:t>
+            </a:r>
+          </a:p>
+          <a:p>
+            <a:pPr algn="l"/>
+            <a:r>
+              <a:rPr sz="1250" b="0">
                 <a:solidFill>
                   <a:srgbClr val="1B2B34"/>
                 </a:solidFill>
                 <a:latin typeface="Consolas"/>
               </a:rPr>
-              <a:t>  result_parse:</a:t>
-            </a:r>
-          </a:p>
-          <a:p>
-            <a:pPr algn="l"/>
-            <a:r>
-              <a:rPr sz="1350" b="0">
+              <a:t>debug:</a:t>
+            </a:r>
+          </a:p>
+          <a:p>
+            <a:pPr algn="l"/>
+            <a:r>
+              <a:rPr sz="1250" b="0">
                 <a:solidFill>
                   <a:srgbClr val="1B2B34"/>
                 </a:solidFill>
                 <a:latin typeface="Consolas"/>
               </a:rPr>
-              <a:t>    regex:</a:t>
-            </a:r>
-          </a:p>
-          <a:p>
-            <a:pPr algn="l"/>
-            <a:r>
-              <a:rPr sz="1350" b="0">
+              <a:t>  inherits_from: base</a:t>
+            </a:r>
+          </a:p>
+          <a:p>
+            <a:pPr algn="l"/>
+            <a:r>
+              <a:rPr sz="1250" b="0">
                 <a:solidFill>
                   <a:srgbClr val="1B2B34"/>
                 </a:solidFill>
                 <a:latin typeface="Consolas"/>
               </a:rPr>
-              <a:t>      triad_mbs: {regex: 'Triad:\s+(\S+)'}</a:t>
-            </a:r>
-          </a:p>
-          <a:p>
-            <a:pPr algn="l"/>
-            <a:r>
-              <a:rPr sz="1350" b="0">
+              <a:t>  build:                     # override just the build flags</a:t>
+            </a:r>
+          </a:p>
+          <a:p>
+            <a:pPr algn="l"/>
+            <a:r>
+              <a:rPr sz="1250" b="0">
                 <a:solidFill>
                   <a:srgbClr val="1B2B34"/>
                 </a:solidFill>
                 <a:latin typeface="Consolas"/>
               </a:rPr>
-              <a:t>  result_evaluate:</a:t>
-            </a:r>
-          </a:p>
-          <a:p>
-            <a:pPr algn="l"/>
-            <a:r>
-              <a:rPr sz="1350" b="0">
-                <a:solidFill>
-                  <a:srgbClr val="1B2B34"/>
-                </a:solidFill>
-                <a:latin typeface="Consolas"/>
-              </a:rPr>
-              <a:t>    result: 'triad_mbs &gt; 10000'    # PASS only if fast enough</a:t>
+              <a:t>    cmds: ['gcc -O3 -fopenmp -fsanitize=address stream.c -o stream']</a:t>
             </a:r>
           </a:p>
         </p:txBody>

</xml_diff>

<commit_message>
Permutations: one PBS job per instance (share_allocation: false) + block YAML
- demo_perms.yaml: add schedule.share_allocation: false so each permutation
  kicks off its OWN PBS job (default packs them into one shared allocation).
  Verified live: 6 distinct jobs 8400-8405 (2 running, 4 queued), all PASS.
- Slide 22 (Permutations expand) rebuilt with the real 6-job qstat + per-test
  job ids. Permutations code slide shows share_allocation: false.
- Slide 32 (A series file) converted from inline flow YAML to expanded block
  style (dashes) for readability — Curtis's standing preference for deck YAML.

Co-Authored-By: Claude Opus 4.8 (1M context) <noreply@anthropic.com>
</commit_message>
<xml_diff>
--- a/pavilion-workshop.pptx
+++ b/pavilion-workshop.pptx
@@ -1040,7 +1040,7 @@
           <a:lstStyle/>
           <a:p>
             <a:r>
-              <a:t>The feature people remember. One definition, six tests, each with its own subtitle.</a:t>
+              <a:t>The feature people remember. One definition, six tests, each with its own subtitle. share_allocation: false makes Pavilion submit a separate PBS job per instance (the default packs them into one shared allocation).</a:t>
             </a:r>
           </a:p>
         </p:txBody>
@@ -1110,7 +1110,7 @@
           <a:lstStyle/>
           <a:p>
             <a:r>
-              <a:t>Point out the auto-generated subtitles (size-mode). All six went through PBS (qstat).</a:t>
+              <a:t>share_allocation: false gives each permutation its OWN PBS job (distinct job ids 8400–8405). With one free node they run a couple at a time and the rest sit in Q — real scheduler behavior. Point out the auto-generated subtitles (size-mode).</a:t>
             </a:r>
           </a:p>
         </p:txBody>
@@ -10131,6 +10131,18 @@
                 </a:solidFill>
                 <a:latin typeface="Consolas"/>
               </a:rPr>
+              <a:t>    share_allocation: false      # one PBS job per instance</a:t>
+            </a:r>
+          </a:p>
+          <a:p>
+            <a:pPr algn="l"/>
+            <a:r>
+              <a:rPr sz="1400" b="0">
+                <a:solidFill>
+                  <a:srgbClr val="1B2B34"/>
+                </a:solidFill>
+                <a:latin typeface="Consolas"/>
+              </a:rPr>
               <a:t>    pbs: { queue: workq, nodes: 1, walltime: '00:02:00' }</a:t>
             </a:r>
           </a:p>
@@ -10251,7 +10263,7 @@
                 </a:solidFill>
                 <a:latin typeface="Consolas"/>
               </a:rPr>
-              <a:t># 3 sizes x 2 modes  =&gt;  6 test instances, one config.</a:t>
+              <a:t># 3 sizes x 2 modes  =&gt;  6 test instances, 6 PBS jobs.</a:t>
             </a:r>
           </a:p>
         </p:txBody>
@@ -10510,7 +10522,7 @@
                 </a:solidFill>
                 <a:latin typeface="Consolas"/>
               </a:rPr>
-              <a:t>sid: s72</a:t>
+              <a:t>sid: s93</a:t>
             </a:r>
           </a:p>
           <a:p>
@@ -10534,7 +10546,7 @@
                 </a:solidFill>
                 <a:latin typeface="Consolas"/>
               </a:rPr>
-              <a:t>$ qstat -a                        # all six ride one PBS job</a:t>
+              <a:t>$ qstat -a                        # SIX PBS jobs — one per permutation</a:t>
             </a:r>
           </a:p>
           <a:p>
@@ -10546,7 +10558,7 @@
                 </a:solidFill>
                 <a:latin typeface="Consolas"/>
               </a:rPr>
-              <a:t>8385.pbs-server pavilion workq pav_demo_*  1  1  R</a:t>
+              <a:t>8400.pbs-server pavilion workq pav_demo_*  1  1  R</a:t>
             </a:r>
           </a:p>
           <a:p>
@@ -10558,6 +10570,66 @@
                 </a:solidFill>
                 <a:latin typeface="Consolas"/>
               </a:rPr>
+              <a:t>8401.pbs-server pavilion workq pav_demo_*  1  1  R</a:t>
+            </a:r>
+          </a:p>
+          <a:p>
+            <a:pPr algn="l"/>
+            <a:r>
+              <a:rPr sz="1250" b="0">
+                <a:solidFill>
+                  <a:srgbClr val="1B2B34"/>
+                </a:solidFill>
+                <a:latin typeface="Consolas"/>
+              </a:rPr>
+              <a:t>8402.pbs-server pavilion workq pav_demo_*  1  1  Q</a:t>
+            </a:r>
+          </a:p>
+          <a:p>
+            <a:pPr algn="l"/>
+            <a:r>
+              <a:rPr sz="1250" b="0">
+                <a:solidFill>
+                  <a:srgbClr val="1B2B34"/>
+                </a:solidFill>
+                <a:latin typeface="Consolas"/>
+              </a:rPr>
+              <a:t>8403.pbs-server pavilion workq pav_demo_*  1  1  Q</a:t>
+            </a:r>
+          </a:p>
+          <a:p>
+            <a:pPr algn="l"/>
+            <a:r>
+              <a:rPr sz="1250" b="0">
+                <a:solidFill>
+                  <a:srgbClr val="1B2B34"/>
+                </a:solidFill>
+                <a:latin typeface="Consolas"/>
+              </a:rPr>
+              <a:t>8404.pbs-server pavilion workq pav_demo_*  1  1  Q</a:t>
+            </a:r>
+          </a:p>
+          <a:p>
+            <a:pPr algn="l"/>
+            <a:r>
+              <a:rPr sz="1250" b="0">
+                <a:solidFill>
+                  <a:srgbClr val="1B2B34"/>
+                </a:solidFill>
+                <a:latin typeface="Consolas"/>
+              </a:rPr>
+              <a:t>8405.pbs-server pavilion workq pav_demo_*  1  1  Q</a:t>
+            </a:r>
+          </a:p>
+          <a:p>
+            <a:pPr algn="l"/>
+            <a:r>
+              <a:rPr sz="1250" b="0">
+                <a:solidFill>
+                  <a:srgbClr val="1B2B34"/>
+                </a:solidFill>
+                <a:latin typeface="Consolas"/>
+              </a:rPr>
               <a:t> </a:t>
             </a:r>
           </a:p>
@@ -10570,7 +10642,7 @@
                 </a:solidFill>
                 <a:latin typeface="Consolas"/>
               </a:rPr>
-              <a:t>$ pav status s72</a:t>
+              <a:t>$ pav status s93                  # each instance = its own job id</a:t>
             </a:r>
           </a:p>
           <a:p>
@@ -10582,7 +10654,7 @@
                 </a:solidFill>
                 <a:latin typeface="Consolas"/>
               </a:rPr>
-              <a:t>s72.1  PASS  demo_perms.matrix.small-read</a:t>
+              <a:t>s93.1 | 8400_pbs-server | demo_perms.matrix.small-read  | PASS</a:t>
             </a:r>
           </a:p>
           <a:p>
@@ -10594,7 +10666,7 @@
                 </a:solidFill>
                 <a:latin typeface="Consolas"/>
               </a:rPr>
-              <a:t>s72.2  PASS  demo_perms.matrix.medium-read</a:t>
+              <a:t>s93.2 | 8401_pbs-server | demo_perms.matrix.medium-read | PASS</a:t>
             </a:r>
           </a:p>
           <a:p>
@@ -10606,7 +10678,7 @@
                 </a:solidFill>
                 <a:latin typeface="Consolas"/>
               </a:rPr>
-              <a:t>s72.3  PASS  demo_perms.matrix.large-read</a:t>
+              <a:t>s93.3 | 8402_pbs-server | demo_perms.matrix.large-read  | PASS</a:t>
             </a:r>
           </a:p>
           <a:p>
@@ -10618,7 +10690,7 @@
                 </a:solidFill>
                 <a:latin typeface="Consolas"/>
               </a:rPr>
-              <a:t>s72.4  PASS  demo_perms.matrix.small-write</a:t>
+              <a:t>s93.4 | 8403_pbs-server | demo_perms.matrix.small-write | PASS</a:t>
             </a:r>
           </a:p>
           <a:p>
@@ -10630,7 +10702,7 @@
                 </a:solidFill>
                 <a:latin typeface="Consolas"/>
               </a:rPr>
-              <a:t>s72.5  PASS  demo_perms.matrix.medium-write</a:t>
+              <a:t>s93.5 | 8404_pbs-server | demo_perms.matrix.medium-write| PASS</a:t>
             </a:r>
           </a:p>
           <a:p>
@@ -10642,7 +10714,7 @@
                 </a:solidFill>
                 <a:latin typeface="Consolas"/>
               </a:rPr>
-              <a:t>s72.6  PASS  demo_perms.matrix.large-write</a:t>
+              <a:t>s93.6 | 8405_pbs-server | demo_perms.matrix.large-write | PASS</a:t>
             </a:r>
           </a:p>
         </p:txBody>
@@ -10676,7 +10748,7 @@
                 </a:solidFill>
                 <a:latin typeface="Arial"/>
               </a:rPr>
-              <a:t>One YAML block → six named PBS test instances, all PASS.</a:t>
+              <a:t>One YAML block → six PBS jobs (8400–8405), one per permutation — some run, the rest queue.</a:t>
             </a:r>
           </a:p>
         </p:txBody>
@@ -13285,7 +13357,7 @@
                 </a:solidFill>
                 <a:latin typeface="Consolas"/>
               </a:rPr>
-              <a:t>  smoke:  { tests: [demo_pbs.pass] }</a:t>
+              <a:t>  smoke:</a:t>
             </a:r>
           </a:p>
           <a:p>
@@ -13297,7 +13369,55 @@
                 </a:solidFill>
                 <a:latin typeface="Consolas"/>
               </a:rPr>
-              <a:t>  perf:   { tests: [demo_pbs.metrics] }</a:t>
+              <a:t>    tests:</a:t>
+            </a:r>
+          </a:p>
+          <a:p>
+            <a:pPr algn="l"/>
+            <a:r>
+              <a:rPr sz="1400" b="0">
+                <a:solidFill>
+                  <a:srgbClr val="1B2B34"/>
+                </a:solidFill>
+                <a:latin typeface="Consolas"/>
+              </a:rPr>
+              <a:t>      - demo_pbs.pass</a:t>
+            </a:r>
+          </a:p>
+          <a:p>
+            <a:pPr algn="l"/>
+            <a:r>
+              <a:rPr sz="1400" b="0">
+                <a:solidFill>
+                  <a:srgbClr val="1B2B34"/>
+                </a:solidFill>
+                <a:latin typeface="Consolas"/>
+              </a:rPr>
+              <a:t>  perf:</a:t>
+            </a:r>
+          </a:p>
+          <a:p>
+            <a:pPr algn="l"/>
+            <a:r>
+              <a:rPr sz="1400" b="0">
+                <a:solidFill>
+                  <a:srgbClr val="1B2B34"/>
+                </a:solidFill>
+                <a:latin typeface="Consolas"/>
+              </a:rPr>
+              <a:t>    tests:</a:t>
+            </a:r>
+          </a:p>
+          <a:p>
+            <a:pPr algn="l"/>
+            <a:r>
+              <a:rPr sz="1400" b="0">
+                <a:solidFill>
+                  <a:srgbClr val="1B2B34"/>
+                </a:solidFill>
+                <a:latin typeface="Consolas"/>
+              </a:rPr>
+              <a:t>      - demo_pbs.metrics</a:t>
             </a:r>
           </a:p>
         </p:txBody>

</xml_diff>

<commit_message>
Merge disk-usage into the Custom commands slide (use the empty space)
Slide 39 had room to spare; folded the standalone disk-usage slide into it as
a 4th step (out_size 11.5, output trimmed to the essentials). Deck 49 -> 48
slides. Render-verified the merged slide fits.

Co-Authored-By: Claude Opus 4.8 (1M context) <noreply@anthropic.com>
</commit_message>
<xml_diff>
--- a/pavilion-workshop.pptx
+++ b/pavilion-workshop.pptx
@@ -53,7 +53,6 @@
     <p:sldId id="301" r:id="rId53"/>
     <p:sldId id="302" r:id="rId54"/>
     <p:sldId id="303" r:id="rId55"/>
-    <p:sldId id="304" r:id="rId56"/>
   </p:sldIdLst>
   <p:sldSz cx="12191695" cy="6858000" type="screen4x3"/>
   <p:notesSz cx="6858000" cy="9144000"/>
@@ -2020,7 +2019,7 @@
           <a:lstStyle/>
           <a:p>
             <a:r>
-              <a:t>recent/test-summary read Pavilion's own run database via cmd_utils.</a:t>
+              <a:t>hello/recent/test-summary/disk-usage all add new verbs to pav itself. recent/test-summary read Pavilion's run database via cmd_utils; disk-usage totals runs / builds / series (handy before a 'pav clean'). Same plugin API for all four.</a:t>
             </a:r>
           </a:p>
         </p:txBody>
@@ -2160,7 +2159,7 @@
           <a:lstStyle/>
           <a:p>
             <a:r>
-              <a:t>disk-usage walks Pavilion's working dir and totals runs / builds / series. Handy for spotting when old builds need a 'pav clean'. Same plugin API as hello/recent/test-summary.</a:t>
+              <a:t>Result loggers run at the end of the results stage. One config, applies to all runs. (Redact the OpenSearch password if you ever show pavilion.yaml.)</a:t>
             </a:r>
           </a:p>
         </p:txBody>
@@ -2230,7 +2229,7 @@
           <a:lstStyle/>
           <a:p>
             <a:r>
-              <a:t>Result loggers run at the end of the results stage. One config, applies to all runs. (Redact the OpenSearch password if you ever show pavilion.yaml.)</a:t>
+              <a:t>The CSV page also shows scheduler dispatch — these are real PBS jobs (qstat) — then the csv_file logger records one row per test. Parsed metrics land in 'extra', permute vars in 'permute_on'.</a:t>
             </a:r>
           </a:p>
         </p:txBody>
@@ -2300,7 +2299,7 @@
           <a:lstStyle/>
           <a:p>
             <a:r>
-              <a:t>The CSV page also shows scheduler dispatch — these are real PBS jobs (qstat) — then the csv_file logger records one row per test. Parsed metrics land in 'extra', permute vars in 'permute_on'.</a:t>
+              <a:t>saLog is a logger specific to us (NASA/NOAA). Pavilion's sa_log result plugin invokes it as nodes are released from the PBS job — one CSV row per node, with the test result. It writes node(s), content (result), user, and the 'released' action.</a:t>
             </a:r>
           </a:p>
         </p:txBody>
@@ -2370,7 +2369,7 @@
           <a:lstStyle/>
           <a:p>
             <a:r>
-              <a:t>saLog is a logger specific to us (NASA/NOAA). Pavilion's sa_log result plugin invokes it as nodes are released from the PBS job — one CSV row per node, with the test result. It writes node(s), content (result), user, and the 'released' action.</a:t>
+              <a:t>Run the suite, query the index to prove indexing, then open Grafana (http://&lt;your-grafana-host&gt;:3000). Export OS_PASS before the demo.</a:t>
             </a:r>
           </a:p>
         </p:txBody>
@@ -2440,7 +2439,7 @@
           <a:lstStyle/>
           <a:p>
             <a:r>
-              <a:t>Run the suite, query the index to prove indexing, then open Grafana (http://&lt;your-grafana-host&gt;:3000). Export OS_PASS before the demo.</a:t>
+              <a:t>Built with pymysql; connects via unix_socket so there's NO password in pavilion.yaml. The row-per-test appears the moment the run finishes.</a:t>
             </a:r>
           </a:p>
         </p:txBody>
@@ -2510,7 +2509,7 @@
           <a:lstStyle/>
           <a:p>
             <a:r>
-              <a:t>Built with pymysql; connects via unix_socket so there's NO password in pavilion.yaml. The row-per-test appears the moment the run finishes.</a:t>
+              <a:t>The point: loggers are plugins, so results can go wherever you need. csv_file / saLog / opensearch / mysql all exist and are shown today; PostgreSQL is an example you'd write a logger for — '[add your own]' says exactly that.</a:t>
             </a:r>
           </a:p>
         </p:txBody>
@@ -2580,7 +2579,7 @@
           <a:lstStyle/>
           <a:p>
             <a:r>
-              <a:t>The point: loggers are plugins, so results can go wherever you need. csv_file / saLog / opensearch / mysql all exist and are shown today; PostgreSQL is an example you'd write a logger for — '[add your own]' says exactly that.</a:t>
+              <a:t>Pavilion isn't just running tests — it's a data pipeline from 'did it pass' to 'how is the system trending'.</a:t>
             </a:r>
           </a:p>
         </p:txBody>
@@ -2606,76 +2605,6 @@
 </file>
 
 <file path=ppt/notesSlides/notesSlide37.xml><?xml version="1.0" encoding="utf-8"?>
-<p:notes xmlns:a="http://schemas.openxmlformats.org/drawingml/2006/main" xmlns:p="http://schemas.openxmlformats.org/presentationml/2006/main" xmlns:r="http://schemas.openxmlformats.org/officeDocument/2006/relationships">
-  <p:cSld>
-    <p:spTree>
-      <p:nvGrpSpPr>
-        <p:cNvPr id="1" name=""/>
-        <p:cNvGrpSpPr/>
-        <p:nvPr/>
-      </p:nvGrpSpPr>
-      <p:grpSpPr>
-        <a:xfrm>
-          <a:off x="0" y="0"/>
-          <a:ext cx="0" cy="0"/>
-          <a:chOff x="0" y="0"/>
-          <a:chExt cx="0" cy="0"/>
-        </a:xfrm>
-      </p:grpSpPr>
-      <p:sp>
-        <p:nvSpPr>
-          <p:cNvPr id="2" name="Slide Image Placeholder 1"/>
-          <p:cNvSpPr>
-            <a:spLocks noGrp="1"/>
-          </p:cNvSpPr>
-          <p:nvPr>
-            <p:ph type="sldImg" idx="2"/>
-          </p:nvPr>
-        </p:nvSpPr>
-        <p:spPr/>
-      </p:sp>
-      <p:sp>
-        <p:nvSpPr>
-          <p:cNvPr id="3" name="Notes Placeholder 2"/>
-          <p:cNvSpPr>
-            <a:spLocks noGrp="1"/>
-          </p:cNvSpPr>
-          <p:nvPr>
-            <p:ph type="body" idx="3" sz="quarter"/>
-          </p:nvPr>
-        </p:nvSpPr>
-        <p:spPr/>
-        <p:txBody>
-          <a:bodyPr/>
-          <a:lstStyle/>
-          <a:p>
-            <a:r>
-              <a:t>Pavilion isn't just running tests — it's a data pipeline from 'did it pass' to 'how is the system trending'.</a:t>
-            </a:r>
-          </a:p>
-        </p:txBody>
-      </p:sp>
-      <p:sp>
-        <p:nvSpPr>
-          <p:cNvPr id="4" name="Slide Number Placeholder 3"/>
-          <p:cNvSpPr>
-            <a:spLocks noGrp="1"/>
-          </p:cNvSpPr>
-          <p:nvPr>
-            <p:ph type="sldNum" idx="5" sz="quarter"/>
-          </p:nvPr>
-        </p:nvSpPr>
-        <p:spPr/>
-      </p:sp>
-    </p:spTree>
-  </p:cSld>
-  <p:clrMapOvr>
-    <a:masterClrMapping/>
-  </p:clrMapOvr>
-</p:notes>
-</file>
-
-<file path=ppt/notesSlides/notesSlide38.xml><?xml version="1.0" encoding="utf-8"?>
 <p:notes xmlns:a="http://schemas.openxmlformats.org/drawingml/2006/main" xmlns:p="http://schemas.openxmlformats.org/presentationml/2006/main" xmlns:r="http://schemas.openxmlformats.org/officeDocument/2006/relationships">
   <p:cSld>
     <p:spTree>
@@ -15096,7 +15025,7 @@
           <a:p>
             <a:pPr algn="l"/>
             <a:r>
-              <a:rPr sz="1250" b="0">
+              <a:rPr sz="1150" b="0">
                 <a:solidFill>
                   <a:srgbClr val="1B2B34"/>
                 </a:solidFill>
@@ -15108,7 +15037,7 @@
           <a:p>
             <a:pPr algn="l"/>
             <a:r>
-              <a:rPr sz="1250" b="0">
+              <a:rPr sz="1150" b="0">
                 <a:solidFill>
                   <a:srgbClr val="1B2B34"/>
                 </a:solidFill>
@@ -15132,7 +15061,7 @@
           <a:p>
             <a:pPr algn="l"/>
             <a:r>
-              <a:rPr sz="1250" b="0">
+              <a:rPr sz="1150" b="0">
                 <a:solidFill>
                   <a:srgbClr val="1E7D3C"/>
                 </a:solidFill>
@@ -15144,7 +15073,7 @@
           <a:p>
             <a:pPr algn="l"/>
             <a:r>
-              <a:rPr sz="1250" b="0">
+              <a:rPr sz="1150" b="0">
                 <a:solidFill>
                   <a:srgbClr val="1E7D3C"/>
                 </a:solidFill>
@@ -15156,7 +15085,7 @@
           <a:p>
             <a:pPr algn="l"/>
             <a:r>
-              <a:rPr sz="1250" b="0">
+              <a:rPr sz="1150" b="0">
                 <a:solidFill>
                   <a:srgbClr val="B32A2A"/>
                 </a:solidFill>
@@ -15168,7 +15097,7 @@
           <a:p>
             <a:pPr algn="l"/>
             <a:r>
-              <a:rPr sz="1250" b="0">
+              <a:rPr sz="1150" b="0">
                 <a:solidFill>
                   <a:srgbClr val="1B2B34"/>
                 </a:solidFill>
@@ -15192,13 +15121,109 @@
           <a:p>
             <a:pPr algn="l"/>
             <a:r>
-              <a:rPr sz="1250" b="0">
+              <a:rPr sz="1150" b="0">
                 <a:solidFill>
                   <a:srgbClr val="1E7D3C"/>
                 </a:solidFill>
                 <a:latin typeface="Consolas"/>
               </a:rPr>
               <a:t>PASS: 74    FAIL: 8    TOTAL: 83</a:t>
+            </a:r>
+          </a:p>
+          <a:p>
+            <a:pPr algn="l"/>
+            <a:r>
+              <a:rPr sz="1150" b="0">
+                <a:solidFill>
+                  <a:srgbClr val="1B2B34"/>
+                </a:solidFill>
+                <a:latin typeface="Consolas"/>
+              </a:rPr>
+              <a:t> </a:t>
+            </a:r>
+          </a:p>
+          <a:p>
+            <a:pPr algn="l"/>
+            <a:r>
+              <a:rPr sz="1400" b="1">
+                <a:solidFill>
+                  <a:srgbClr val="2E6DA4"/>
+                </a:solidFill>
+                <a:latin typeface="Consolas"/>
+              </a:rPr>
+              <a:t>$ pav disk-usage        # where the space goes</a:t>
+            </a:r>
+          </a:p>
+          <a:p>
+            <a:pPr algn="l"/>
+            <a:r>
+              <a:rPr sz="1150" b="0">
+                <a:solidFill>
+                  <a:srgbClr val="1B2B34"/>
+                </a:solidFill>
+                <a:latin typeface="Consolas"/>
+              </a:rPr>
+              <a:t>Config Area: main</a:t>
+            </a:r>
+          </a:p>
+          <a:p>
+            <a:pPr algn="l"/>
+            <a:r>
+              <a:rPr sz="1150" b="0">
+                <a:solidFill>
+                  <a:srgbClr val="1B2B34"/>
+                </a:solidFill>
+                <a:latin typeface="Consolas"/>
+              </a:rPr>
+              <a:t>  Test Runs:     4.42 MB</a:t>
+            </a:r>
+          </a:p>
+          <a:p>
+            <a:pPr algn="l"/>
+            <a:r>
+              <a:rPr sz="1150" b="0">
+                <a:solidFill>
+                  <a:srgbClr val="1B2B34"/>
+                </a:solidFill>
+                <a:latin typeface="Consolas"/>
+              </a:rPr>
+              <a:t>  Builds:       59.77 MB</a:t>
+            </a:r>
+          </a:p>
+          <a:p>
+            <a:pPr algn="l"/>
+            <a:r>
+              <a:rPr sz="1150" b="0">
+                <a:solidFill>
+                  <a:srgbClr val="1B2B34"/>
+                </a:solidFill>
+                <a:latin typeface="Consolas"/>
+              </a:rPr>
+              <a:t>Series:          16.84 MB</a:t>
+            </a:r>
+          </a:p>
+          <a:p>
+            <a:pPr algn="l"/>
+            <a:r>
+              <a:rPr sz="1150" b="0">
+                <a:solidFill>
+                  <a:srgbClr val="1B2B34"/>
+                </a:solidFill>
+                <a:latin typeface="Consolas"/>
+              </a:rPr>
+              <a:t>------------------------------------------------</a:t>
+            </a:r>
+          </a:p>
+          <a:p>
+            <a:pPr algn="l"/>
+            <a:r>
+              <a:rPr sz="1150" b="0">
+                <a:solidFill>
+                  <a:srgbClr val="1B2B34"/>
+                </a:solidFill>
+                <a:latin typeface="Consolas"/>
+              </a:rPr>
+              <a:t>TOTAL USAGE:    145.22 MB</a:t>
             </a:r>
           </a:p>
         </p:txBody>
@@ -15232,7 +15257,7 @@
                 </a:solidFill>
                 <a:latin typeface="Arial"/>
               </a:rPr>
-              <a:t>New pav subcommands — our own tooling built on Pavilion's plugin API.</a:t>
+              <a:t>Four new pav subcommands — our own tooling built on Pavilion's plugin API.</a:t>
             </a:r>
           </a:p>
         </p:txBody>
@@ -15516,7 +15541,7 @@
                 </a:solidFill>
                 <a:latin typeface="Arial"/>
               </a:rPr>
-              <a:t>LIVE DEMO · L7 · DISK-USAGE</a:t>
+              <a:t>CUSTOM OUTPUT</a:t>
             </a:r>
           </a:p>
         </p:txBody>
@@ -15550,7 +15575,7 @@
                 </a:solidFill>
                 <a:latin typeface="Arial"/>
               </a:rPr>
-              <a:t>Disk usage at a glance</a:t>
+              <a:t>Result loggers (ours)</a:t>
             </a:r>
           </a:p>
         </p:txBody>
@@ -15600,216 +15625,14 @@
       </p:sp>
       <p:sp>
         <p:nvSpPr>
-          <p:cNvPr id="5" name="Rectangle 4"/>
-          <p:cNvSpPr/>
-          <p:nvPr/>
-        </p:nvSpPr>
-        <p:spPr>
-          <a:xfrm>
-            <a:off x="8503920" y="457200"/>
-            <a:ext cx="3108960" cy="502920"/>
-          </a:xfrm>
-          <a:prstGeom prst="rect">
-            <a:avLst/>
-          </a:prstGeom>
-          <a:solidFill>
-            <a:srgbClr val="2E6DA4"/>
-          </a:solidFill>
-          <a:ln>
-            <a:noFill/>
-          </a:ln>
-        </p:spPr>
-        <p:style>
-          <a:lnRef idx="1">
-            <a:schemeClr val="accent1"/>
-          </a:lnRef>
-          <a:fillRef idx="3">
-            <a:schemeClr val="accent1"/>
-          </a:fillRef>
-          <a:effectRef idx="2">
-            <a:schemeClr val="accent1"/>
-          </a:effectRef>
-          <a:fontRef idx="minor">
-            <a:schemeClr val="lt1"/>
-          </a:fontRef>
-        </p:style>
-        <p:txBody>
-          <a:bodyPr rtlCol="0" anchor="ctr" wrap="square"/>
-          <a:lstStyle/>
-          <a:p>
-            <a:pPr algn="ctr"/>
-            <a:r>
-              <a:rPr sz="1300" b="1">
-                <a:solidFill>
-                  <a:srgbClr val="FFFFFF"/>
-                </a:solidFill>
-                <a:latin typeface="Arial"/>
-              </a:rPr>
-              <a:t>▶  07-command-plugins.sh</a:t>
-            </a:r>
-          </a:p>
-        </p:txBody>
-      </p:sp>
-      <p:sp>
-        <p:nvSpPr>
-          <p:cNvPr id="6" name="Rectangle 5"/>
-          <p:cNvSpPr/>
-          <p:nvPr/>
-        </p:nvSpPr>
-        <p:spPr>
-          <a:xfrm>
-            <a:off x="640080" y="1645920"/>
-            <a:ext cx="10972800" cy="4343400"/>
-          </a:xfrm>
-          <a:prstGeom prst="rect">
-            <a:avLst/>
-          </a:prstGeom>
-          <a:solidFill>
-            <a:srgbClr val="F3F4F6"/>
-          </a:solidFill>
-          <a:ln w="12700">
-            <a:solidFill>
-              <a:srgbClr val="D5DAE0"/>
-            </a:solidFill>
-          </a:ln>
-        </p:spPr>
-        <p:style>
-          <a:lnRef idx="1">
-            <a:schemeClr val="accent1"/>
-          </a:lnRef>
-          <a:fillRef idx="3">
-            <a:schemeClr val="accent1"/>
-          </a:fillRef>
-          <a:effectRef idx="2">
-            <a:schemeClr val="accent1"/>
-          </a:effectRef>
-          <a:fontRef idx="minor">
-            <a:schemeClr val="lt1"/>
-          </a:fontRef>
-        </p:style>
-        <p:txBody>
-          <a:bodyPr rtlCol="0" anchor="t" wrap="square" lIns="228600" tIns="146304"/>
-          <a:lstStyle/>
-          <a:p>
-            <a:pPr algn="l"/>
-            <a:r>
-              <a:rPr sz="1400" b="1">
-                <a:solidFill>
-                  <a:srgbClr val="2E6DA4"/>
-                </a:solidFill>
-                <a:latin typeface="Consolas"/>
-              </a:rPr>
-              <a:t>$ pav disk-usage        # our command plugin: where the space goes</a:t>
-            </a:r>
-          </a:p>
-          <a:p>
-            <a:pPr algn="l"/>
-            <a:r>
-              <a:rPr sz="1250" b="0">
-                <a:solidFill>
-                  <a:srgbClr val="1B2B34"/>
-                </a:solidFill>
-                <a:latin typeface="Consolas"/>
-              </a:rPr>
-              <a:t>Config Area: main</a:t>
-            </a:r>
-          </a:p>
-          <a:p>
-            <a:pPr algn="l"/>
-            <a:r>
-              <a:rPr sz="1250" b="0">
-                <a:solidFill>
-                  <a:srgbClr val="1B2B34"/>
-                </a:solidFill>
-                <a:latin typeface="Consolas"/>
-              </a:rPr>
-              <a:t>  Working Dir: /home/pavilion/pavilion2/working_dir</a:t>
-            </a:r>
-          </a:p>
-          <a:p>
-            <a:pPr algn="l"/>
-            <a:r>
-              <a:rPr sz="1250" b="0">
-                <a:solidFill>
-                  <a:srgbClr val="1B2B34"/>
-                </a:solidFill>
-                <a:latin typeface="Consolas"/>
-              </a:rPr>
-              <a:t>  Test Runs:     4.42 MB</a:t>
-            </a:r>
-          </a:p>
-          <a:p>
-            <a:pPr algn="l"/>
-            <a:r>
-              <a:rPr sz="1250" b="0">
-                <a:solidFill>
-                  <a:srgbClr val="1B2B34"/>
-                </a:solidFill>
-                <a:latin typeface="Consolas"/>
-              </a:rPr>
-              <a:t>  Builds:       59.77 MB</a:t>
-            </a:r>
-          </a:p>
-          <a:p>
-            <a:pPr algn="l"/>
-            <a:r>
-              <a:rPr sz="1250" b="0">
-                <a:solidFill>
-                  <a:srgbClr val="1B2B34"/>
-                </a:solidFill>
-                <a:latin typeface="Consolas"/>
-              </a:rPr>
-              <a:t> </a:t>
-            </a:r>
-          </a:p>
-          <a:p>
-            <a:pPr algn="l"/>
-            <a:r>
-              <a:rPr sz="1250" b="0">
-                <a:solidFill>
-                  <a:srgbClr val="1B2B34"/>
-                </a:solidFill>
-                <a:latin typeface="Consolas"/>
-              </a:rPr>
-              <a:t>Series:          16.84 MB</a:t>
-            </a:r>
-          </a:p>
-          <a:p>
-            <a:pPr algn="l"/>
-            <a:r>
-              <a:rPr sz="1250" b="0">
-                <a:solidFill>
-                  <a:srgbClr val="1B2B34"/>
-                </a:solidFill>
-                <a:latin typeface="Consolas"/>
-              </a:rPr>
-              <a:t>------------------------------------------------------------</a:t>
-            </a:r>
-          </a:p>
-          <a:p>
-            <a:pPr algn="l"/>
-            <a:r>
-              <a:rPr sz="1250" b="0">
-                <a:solidFill>
-                  <a:srgbClr val="1B2B34"/>
-                </a:solidFill>
-                <a:latin typeface="Consolas"/>
-              </a:rPr>
-              <a:t>TOTAL USAGE:    145.22 MB</a:t>
-            </a:r>
-          </a:p>
-        </p:txBody>
-      </p:sp>
-      <p:sp>
-        <p:nvSpPr>
-          <p:cNvPr id="7" name="TextBox 6"/>
+          <p:cNvPr id="5" name="TextBox 4"/>
           <p:cNvSpPr txBox="1"/>
           <p:nvPr/>
         </p:nvSpPr>
         <p:spPr>
           <a:xfrm>
-            <a:off x="640080" y="6144768"/>
-            <a:ext cx="10972800" cy="502920"/>
+            <a:off x="640080" y="1691640"/>
+            <a:ext cx="10972800" cy="4754880"/>
           </a:xfrm>
           <a:prstGeom prst="rect">
             <a:avLst/>
@@ -15822,14 +15645,67 @@
           </a:bodyPr>
           <a:lstStyle/>
           <a:p>
-            <a:r>
-              <a:rPr sz="1400" b="0">
-                <a:solidFill>
-                  <a:srgbClr val="5B6674"/>
-                </a:solidFill>
-                <a:latin typeface="Arial"/>
-              </a:rPr>
-              <a:t>Another command plugin — a quick accounting of what test runs, builds, and series consume.</a:t>
+            <a:pPr>
+              <a:spcAft>
+                <a:spcPts val="1000"/>
+              </a:spcAft>
+            </a:pPr>
+            <a:r>
+              <a:rPr sz="2000" b="0">
+                <a:solidFill>
+                  <a:srgbClr val="21252B"/>
+                </a:solidFill>
+                <a:latin typeface="Arial"/>
+              </a:rPr>
+              <a:t>•  csv_file — appends one CSV row per test (result, duration, metrics, permute vars).</a:t>
+            </a:r>
+          </a:p>
+          <a:p>
+            <a:pPr>
+              <a:spcAft>
+                <a:spcPts val="1000"/>
+              </a:spcAft>
+            </a:pPr>
+            <a:r>
+              <a:rPr sz="2000" b="0">
+                <a:solidFill>
+                  <a:srgbClr val="21252B"/>
+                </a:solidFill>
+                <a:latin typeface="Arial"/>
+              </a:rPr>
+              <a:t>•  saLog — a custom NASA/NOAA logger; writes a CSV row on result 'released'.</a:t>
+            </a:r>
+          </a:p>
+          <a:p>
+            <a:pPr>
+              <a:spcAft>
+                <a:spcPts val="1000"/>
+              </a:spcAft>
+            </a:pPr>
+            <a:r>
+              <a:rPr sz="2000" b="0">
+                <a:solidFill>
+                  <a:srgbClr val="21252B"/>
+                </a:solidFill>
+                <a:latin typeface="Arial"/>
+              </a:rPr>
+              <a:t>•  opensearch — ships each result document into the `pavilion-results` index.</a:t>
+            </a:r>
+          </a:p>
+          <a:p>
+            <a:pPr>
+              <a:spcAft>
+                <a:spcPts val="1000"/>
+              </a:spcAft>
+            </a:pPr>
+            <a:r>
+              <a:rPr sz="2000" b="0">
+                <a:solidFill>
+                  <a:srgbClr val="21252B"/>
+                </a:solidFill>
+                <a:latin typeface="Arial"/>
+              </a:rPr>
+              <a:t>•  Configured once in pavilion.yaml → every test result flows through them.</a:t>
             </a:r>
           </a:p>
         </p:txBody>
@@ -15881,7 +15757,7 @@
                 </a:solidFill>
                 <a:latin typeface="Arial"/>
               </a:rPr>
-              <a:t>CUSTOM OUTPUT</a:t>
+              <a:t>LIVE DEMO · L8</a:t>
             </a:r>
           </a:p>
         </p:txBody>
@@ -15915,7 +15791,7 @@
                 </a:solidFill>
                 <a:latin typeface="Arial"/>
               </a:rPr>
-              <a:t>Result loggers (ours)</a:t>
+              <a:t>Output plugin: CSV</a:t>
             </a:r>
           </a:p>
         </p:txBody>
@@ -15965,14 +15841,240 @@
       </p:sp>
       <p:sp>
         <p:nvSpPr>
-          <p:cNvPr id="5" name="TextBox 4"/>
+          <p:cNvPr id="5" name="Rectangle 4"/>
+          <p:cNvSpPr/>
+          <p:nvPr/>
+        </p:nvSpPr>
+        <p:spPr>
+          <a:xfrm>
+            <a:off x="8503920" y="457200"/>
+            <a:ext cx="3108960" cy="502920"/>
+          </a:xfrm>
+          <a:prstGeom prst="rect">
+            <a:avLst/>
+          </a:prstGeom>
+          <a:solidFill>
+            <a:srgbClr val="2E6DA4"/>
+          </a:solidFill>
+          <a:ln>
+            <a:noFill/>
+          </a:ln>
+        </p:spPr>
+        <p:style>
+          <a:lnRef idx="1">
+            <a:schemeClr val="accent1"/>
+          </a:lnRef>
+          <a:fillRef idx="3">
+            <a:schemeClr val="accent1"/>
+          </a:fillRef>
+          <a:effectRef idx="2">
+            <a:schemeClr val="accent1"/>
+          </a:effectRef>
+          <a:fontRef idx="minor">
+            <a:schemeClr val="lt1"/>
+          </a:fontRef>
+        </p:style>
+        <p:txBody>
+          <a:bodyPr rtlCol="0" anchor="ctr" wrap="square"/>
+          <a:lstStyle/>
+          <a:p>
+            <a:pPr algn="ctr"/>
+            <a:r>
+              <a:rPr sz="1300" b="1">
+                <a:solidFill>
+                  <a:srgbClr val="FFFFFF"/>
+                </a:solidFill>
+                <a:latin typeface="Arial"/>
+              </a:rPr>
+              <a:t>▶  08-output-csv.sh</a:t>
+            </a:r>
+          </a:p>
+        </p:txBody>
+      </p:sp>
+      <p:sp>
+        <p:nvSpPr>
+          <p:cNvPr id="6" name="Rectangle 5"/>
+          <p:cNvSpPr/>
+          <p:nvPr/>
+        </p:nvSpPr>
+        <p:spPr>
+          <a:xfrm>
+            <a:off x="640080" y="1645920"/>
+            <a:ext cx="10972800" cy="4343400"/>
+          </a:xfrm>
+          <a:prstGeom prst="rect">
+            <a:avLst/>
+          </a:prstGeom>
+          <a:solidFill>
+            <a:srgbClr val="F3F4F6"/>
+          </a:solidFill>
+          <a:ln w="12700">
+            <a:solidFill>
+              <a:srgbClr val="D5DAE0"/>
+            </a:solidFill>
+          </a:ln>
+        </p:spPr>
+        <p:style>
+          <a:lnRef idx="1">
+            <a:schemeClr val="accent1"/>
+          </a:lnRef>
+          <a:fillRef idx="3">
+            <a:schemeClr val="accent1"/>
+          </a:fillRef>
+          <a:effectRef idx="2">
+            <a:schemeClr val="accent1"/>
+          </a:effectRef>
+          <a:fontRef idx="minor">
+            <a:schemeClr val="lt1"/>
+          </a:fontRef>
+        </p:style>
+        <p:txBody>
+          <a:bodyPr rtlCol="0" anchor="t" wrap="square" lIns="228600" tIns="146304"/>
+          <a:lstStyle/>
+          <a:p>
+            <a:pPr algn="l"/>
+            <a:r>
+              <a:rPr sz="1400" b="1">
+                <a:solidFill>
+                  <a:srgbClr val="2E6DA4"/>
+                </a:solidFill>
+                <a:latin typeface="Consolas"/>
+              </a:rPr>
+              <a:t>$ pav run demo_pbs.pass demo_pbs.metrics      # real PBS jobs</a:t>
+            </a:r>
+          </a:p>
+          <a:p>
+            <a:pPr algn="l"/>
+            <a:r>
+              <a:rPr sz="1150" b="0">
+                <a:solidFill>
+                  <a:srgbClr val="1B2B34"/>
+                </a:solidFill>
+                <a:latin typeface="Consolas"/>
+              </a:rPr>
+              <a:t>sid: s74</a:t>
+            </a:r>
+          </a:p>
+          <a:p>
+            <a:pPr algn="l"/>
+            <a:r>
+              <a:rPr sz="1150" b="0">
+                <a:solidFill>
+                  <a:srgbClr val="1B2B34"/>
+                </a:solidFill>
+                <a:latin typeface="Consolas"/>
+              </a:rPr>
+              <a:t>tests: 2</a:t>
+            </a:r>
+          </a:p>
+          <a:p>
+            <a:pPr algn="l"/>
+            <a:r>
+              <a:rPr sz="1150" b="0">
+                <a:solidFill>
+                  <a:srgbClr val="1B2B34"/>
+                </a:solidFill>
+                <a:latin typeface="Consolas"/>
+              </a:rPr>
+              <a:t> </a:t>
+            </a:r>
+          </a:p>
+          <a:p>
+            <a:pPr algn="l"/>
+            <a:r>
+              <a:rPr sz="1400" b="1">
+                <a:solidFill>
+                  <a:srgbClr val="2E6DA4"/>
+                </a:solidFill>
+                <a:latin typeface="Consolas"/>
+              </a:rPr>
+              <a:t>$ qstat -a                                    # yes — it went through the scheduler</a:t>
+            </a:r>
+          </a:p>
+          <a:p>
+            <a:pPr algn="l"/>
+            <a:r>
+              <a:rPr sz="1150" b="0">
+                <a:solidFill>
+                  <a:srgbClr val="1B2B34"/>
+                </a:solidFill>
+                <a:latin typeface="Consolas"/>
+              </a:rPr>
+              <a:t>8387.pbs-server  pavilion  workq  pav_demo_*  1  1  R</a:t>
+            </a:r>
+          </a:p>
+          <a:p>
+            <a:pPr algn="l"/>
+            <a:r>
+              <a:rPr sz="1150" b="0">
+                <a:solidFill>
+                  <a:srgbClr val="1B2B34"/>
+                </a:solidFill>
+                <a:latin typeface="Consolas"/>
+              </a:rPr>
+              <a:t> </a:t>
+            </a:r>
+          </a:p>
+          <a:p>
+            <a:pPr algn="l"/>
+            <a:r>
+              <a:rPr sz="1400" b="1">
+                <a:solidFill>
+                  <a:srgbClr val="2E6DA4"/>
+                </a:solidFill>
+                <a:latin typeface="Consolas"/>
+              </a:rPr>
+              <a:t>$ tail ~/pav_logs/results.csv                 # csv_file logger: one row per test</a:t>
+            </a:r>
+          </a:p>
+          <a:p>
+            <a:pPr algn="l"/>
+            <a:r>
+              <a:rPr sz="1150" b="0">
+                <a:solidFill>
+                  <a:srgbClr val="1B2B34"/>
+                </a:solidFill>
+                <a:latin typeface="Consolas"/>
+              </a:rPr>
+              <a:t>name,id,result,sys_name,user, ... ,duration</a:t>
+            </a:r>
+          </a:p>
+          <a:p>
+            <a:pPr algn="l"/>
+            <a:r>
+              <a:rPr sz="1150" b="0">
+                <a:solidFill>
+                  <a:srgbClr val="1E7D3C"/>
+                </a:solidFill>
+                <a:latin typeface="Consolas"/>
+              </a:rPr>
+              <a:t>demo_pbs.pass,s74.1,PASS,pbs-server,pavilion, ... ,0.043</a:t>
+            </a:r>
+          </a:p>
+          <a:p>
+            <a:pPr algn="l"/>
+            <a:r>
+              <a:rPr sz="1150" b="0">
+                <a:solidFill>
+                  <a:srgbClr val="1E7D3C"/>
+                </a:solidFill>
+                <a:latin typeface="Consolas"/>
+              </a:rPr>
+              <a:t>demo_pbs.metrics,s74.2,PASS,pbs-server,pavilion, ... ,0.040</a:t>
+            </a:r>
+          </a:p>
+        </p:txBody>
+      </p:sp>
+      <p:sp>
+        <p:nvSpPr>
+          <p:cNvPr id="7" name="TextBox 6"/>
           <p:cNvSpPr txBox="1"/>
           <p:nvPr/>
         </p:nvSpPr>
         <p:spPr>
           <a:xfrm>
-            <a:off x="640080" y="1691640"/>
-            <a:ext cx="10972800" cy="4754880"/>
+            <a:off x="640080" y="6144768"/>
+            <a:ext cx="10972800" cy="502920"/>
           </a:xfrm>
           <a:prstGeom prst="rect">
             <a:avLst/>
@@ -15985,67 +16087,14 @@
           </a:bodyPr>
           <a:lstStyle/>
           <a:p>
-            <a:pPr>
-              <a:spcAft>
-                <a:spcPts val="1000"/>
-              </a:spcAft>
-            </a:pPr>
-            <a:r>
-              <a:rPr sz="2000" b="0">
-                <a:solidFill>
-                  <a:srgbClr val="21252B"/>
-                </a:solidFill>
-                <a:latin typeface="Arial"/>
-              </a:rPr>
-              <a:t>•  csv_file — appends one CSV row per test (result, duration, metrics, permute vars).</a:t>
-            </a:r>
-          </a:p>
-          <a:p>
-            <a:pPr>
-              <a:spcAft>
-                <a:spcPts val="1000"/>
-              </a:spcAft>
-            </a:pPr>
-            <a:r>
-              <a:rPr sz="2000" b="0">
-                <a:solidFill>
-                  <a:srgbClr val="21252B"/>
-                </a:solidFill>
-                <a:latin typeface="Arial"/>
-              </a:rPr>
-              <a:t>•  saLog — a custom NASA/NOAA logger; writes a CSV row on result 'released'.</a:t>
-            </a:r>
-          </a:p>
-          <a:p>
-            <a:pPr>
-              <a:spcAft>
-                <a:spcPts val="1000"/>
-              </a:spcAft>
-            </a:pPr>
-            <a:r>
-              <a:rPr sz="2000" b="0">
-                <a:solidFill>
-                  <a:srgbClr val="21252B"/>
-                </a:solidFill>
-                <a:latin typeface="Arial"/>
-              </a:rPr>
-              <a:t>•  opensearch — ships each result document into the `pavilion-results` index.</a:t>
-            </a:r>
-          </a:p>
-          <a:p>
-            <a:pPr>
-              <a:spcAft>
-                <a:spcPts val="1000"/>
-              </a:spcAft>
-            </a:pPr>
-            <a:r>
-              <a:rPr sz="2000" b="0">
-                <a:solidFill>
-                  <a:srgbClr val="21252B"/>
-                </a:solidFill>
-                <a:latin typeface="Arial"/>
-              </a:rPr>
-              <a:t>•  Configured once in pavilion.yaml → every test result flows through them.</a:t>
+            <a:r>
+              <a:rPr sz="1400" b="0">
+                <a:solidFill>
+                  <a:srgbClr val="5B6674"/>
+                </a:solidFill>
+                <a:latin typeface="Arial"/>
+              </a:rPr>
+              <a:t>A real PBS job (qstat proves dispatch), then the csv_file logger writes one row per test.</a:t>
             </a:r>
           </a:p>
         </p:txBody>
@@ -16097,7 +16146,7 @@
                 </a:solidFill>
                 <a:latin typeface="Arial"/>
               </a:rPr>
-              <a:t>LIVE DEMO · L8</a:t>
+              <a:t>LIVE DEMO · SALOG</a:t>
             </a:r>
           </a:p>
         </p:txBody>
@@ -16131,7 +16180,7 @@
                 </a:solidFill>
                 <a:latin typeface="Arial"/>
               </a:rPr>
-              <a:t>Output plugin: CSV</a:t>
+              <a:t>Output plugin: saLog</a:t>
             </a:r>
           </a:p>
         </p:txBody>
@@ -16226,7 +16275,7 @@
                 </a:solidFill>
                 <a:latin typeface="Arial"/>
               </a:rPr>
-              <a:t>▶  08-output-csv.sh</a:t>
+              <a:t>▶  12-salog.sh</a:t>
             </a:r>
           </a:p>
         </p:txBody>
@@ -16280,25 +16329,25 @@
                 </a:solidFill>
                 <a:latin typeface="Consolas"/>
               </a:rPr>
-              <a:t>$ pav run demo_pbs.pass demo_pbs.metrics      # real PBS jobs</a:t>
-            </a:r>
-          </a:p>
-          <a:p>
-            <a:pPr algn="l"/>
-            <a:r>
-              <a:rPr sz="1150" b="0">
+              <a:t>$ pav run demo_pbs.pass demo_pbs.fail    # 1. run in Pavilion</a:t>
+            </a:r>
+          </a:p>
+          <a:p>
+            <a:pPr algn="l"/>
+            <a:r>
+              <a:rPr sz="1250" b="0">
                 <a:solidFill>
                   <a:srgbClr val="1B2B34"/>
                 </a:solidFill>
                 <a:latin typeface="Consolas"/>
               </a:rPr>
-              <a:t>sid: s74</a:t>
-            </a:r>
-          </a:p>
-          <a:p>
-            <a:pPr algn="l"/>
-            <a:r>
-              <a:rPr sz="1150" b="0">
+              <a:t>sid: s70</a:t>
+            </a:r>
+          </a:p>
+          <a:p>
+            <a:pPr algn="l"/>
+            <a:r>
+              <a:rPr sz="1250" b="0">
                 <a:solidFill>
                   <a:srgbClr val="1B2B34"/>
                 </a:solidFill>
@@ -16310,7 +16359,7 @@
           <a:p>
             <a:pPr algn="l"/>
             <a:r>
-              <a:rPr sz="1150" b="0">
+              <a:rPr sz="1250" b="0">
                 <a:solidFill>
                   <a:srgbClr val="1B2B34"/>
                 </a:solidFill>
@@ -16328,25 +16377,25 @@
                 </a:solidFill>
                 <a:latin typeface="Consolas"/>
               </a:rPr>
-              <a:t>$ qstat -a                                    # yes — it went through the scheduler</a:t>
-            </a:r>
-          </a:p>
-          <a:p>
-            <a:pPr algn="l"/>
-            <a:r>
-              <a:rPr sz="1150" b="0">
+              <a:t>$ qstat -a                               # 2. the jobs, running in PBS</a:t>
+            </a:r>
+          </a:p>
+          <a:p>
+            <a:pPr algn="l"/>
+            <a:r>
+              <a:rPr sz="1250" b="0">
                 <a:solidFill>
                   <a:srgbClr val="1B2B34"/>
                 </a:solidFill>
                 <a:latin typeface="Consolas"/>
               </a:rPr>
-              <a:t>8387.pbs-server  pavilion  workq  pav_demo_*  1  1  R</a:t>
-            </a:r>
-          </a:p>
-          <a:p>
-            <a:pPr algn="l"/>
-            <a:r>
-              <a:rPr sz="1150" b="0">
+              <a:t>8383.pbs-server pavilion workq pav_demo_*  1  1  R</a:t>
+            </a:r>
+          </a:p>
+          <a:p>
+            <a:pPr algn="l"/>
+            <a:r>
+              <a:rPr sz="1250" b="0">
                 <a:solidFill>
                   <a:srgbClr val="1B2B34"/>
                 </a:solidFill>
@@ -16364,43 +16413,31 @@
                 </a:solidFill>
                 <a:latin typeface="Consolas"/>
               </a:rPr>
-              <a:t>$ tail ~/pav_logs/results.csv                 # csv_file logger: one row per test</a:t>
-            </a:r>
-          </a:p>
-          <a:p>
-            <a:pPr algn="l"/>
-            <a:r>
-              <a:rPr sz="1150" b="0">
-                <a:solidFill>
-                  <a:srgbClr val="1B2B34"/>
-                </a:solidFill>
-                <a:latin typeface="Consolas"/>
-              </a:rPr>
-              <a:t>name,id,result,sys_name,user, ... ,duration</a:t>
-            </a:r>
-          </a:p>
-          <a:p>
-            <a:pPr algn="l"/>
-            <a:r>
-              <a:rPr sz="1150" b="0">
+              <a:t>$ tail salog_output.txt                  # 3. the CSV saLog wrote on release</a:t>
+            </a:r>
+          </a:p>
+          <a:p>
+            <a:pPr algn="l"/>
+            <a:r>
+              <a:rPr sz="1250" b="0">
                 <a:solidFill>
                   <a:srgbClr val="1E7D3C"/>
                 </a:solidFill>
                 <a:latin typeface="Consolas"/>
               </a:rPr>
-              <a:t>demo_pbs.pass,s74.1,PASS,pbs-server,pavilion, ... ,0.043</a:t>
-            </a:r>
-          </a:p>
-          <a:p>
-            <a:pPr algn="l"/>
-            <a:r>
-              <a:rPr sz="1150" b="0">
-                <a:solidFill>
-                  <a:srgbClr val="1E7D3C"/>
-                </a:solidFill>
-                <a:latin typeface="Consolas"/>
-              </a:rPr>
-              <a:t>demo_pbs.metrics,s74.2,PASS,pbs-server,pavilion, ... ,0.040</a:t>
+              <a:t>x1003c7s7b0n3,"pav_test result=PASS",pavilion,released</a:t>
+            </a:r>
+          </a:p>
+          <a:p>
+            <a:pPr algn="l"/>
+            <a:r>
+              <a:rPr sz="1250" b="0">
+                <a:solidFill>
+                  <a:srgbClr val="B32A2A"/>
+                </a:solidFill>
+                <a:latin typeface="Consolas"/>
+              </a:rPr>
+              <a:t>x1003c7s7b0n1,x1003c7s7b0n2,x1003c7s7b0n3,"pav_test result=FAIL",pavilion,released</a:t>
             </a:r>
           </a:p>
         </p:txBody>
@@ -16434,7 +16471,7 @@
                 </a:solidFill>
                 <a:latin typeface="Arial"/>
               </a:rPr>
-              <a:t>A real PBS job (qstat proves dispatch), then the csv_file logger writes one row per test.</a:t>
+              <a:t>Run in Pavilion → jobs in PBS → saLog writes a CSV row as each node is released.</a:t>
             </a:r>
           </a:p>
         </p:txBody>
@@ -16486,7 +16523,7 @@
                 </a:solidFill>
                 <a:latin typeface="Arial"/>
               </a:rPr>
-              <a:t>LIVE DEMO · SALOG</a:t>
+              <a:t>LIVE DEMO · L9</a:t>
             </a:r>
           </a:p>
         </p:txBody>
@@ -16520,7 +16557,7 @@
                 </a:solidFill>
                 <a:latin typeface="Arial"/>
               </a:rPr>
-              <a:t>Output plugin: saLog</a:t>
+              <a:t>Output plugin: OpenSearch → Grafana</a:t>
             </a:r>
           </a:p>
         </p:txBody>
@@ -16615,7 +16652,7 @@
                 </a:solidFill>
                 <a:latin typeface="Arial"/>
               </a:rPr>
-              <a:t>▶  12-salog.sh</a:t>
+              <a:t>▶  09-opensearch.sh</a:t>
             </a:r>
           </a:p>
         </p:txBody>
@@ -16669,7 +16706,7 @@
                 </a:solidFill>
                 <a:latin typeface="Consolas"/>
               </a:rPr>
-              <a:t>$ pav run demo_pbs.pass demo_pbs.fail    # 1. run in Pavilion</a:t>
+              <a:t>$ pav run -m pbs opensearch_verify        # 4 tests via PBS; each result → OpenSearch</a:t>
             </a:r>
           </a:p>
           <a:p>
@@ -16681,7 +16718,7 @@
                 </a:solidFill>
                 <a:latin typeface="Consolas"/>
               </a:rPr>
-              <a:t>sid: s70</a:t>
+              <a:t>created 4 tests, skipped 0, 0 errors.</a:t>
             </a:r>
           </a:p>
           <a:p>
@@ -16693,7 +16730,7 @@
                 </a:solidFill>
                 <a:latin typeface="Consolas"/>
               </a:rPr>
-              <a:t>tests: 2</a:t>
+              <a:t>sid: s75</a:t>
             </a:r>
           </a:p>
           <a:p>
@@ -16717,7 +16754,7 @@
                 </a:solidFill>
                 <a:latin typeface="Consolas"/>
               </a:rPr>
-              <a:t>$ qstat -a                               # 2. the jobs, running in PBS</a:t>
+              <a:t>$ qstat -a                                # through the scheduler</a:t>
             </a:r>
           </a:p>
           <a:p>
@@ -16729,7 +16766,7 @@
                 </a:solidFill>
                 <a:latin typeface="Consolas"/>
               </a:rPr>
-              <a:t>8383.pbs-server pavilion workq pav_demo_*  1  1  R</a:t>
+              <a:t>8389.pbs-server pavilion workq pav_opens*  1  1  R</a:t>
             </a:r>
           </a:p>
           <a:p>
@@ -16753,7 +16790,7 @@
                 </a:solidFill>
                 <a:latin typeface="Consolas"/>
               </a:rPr>
-              <a:t>$ tail salog_output.txt                  # 3. the CSV saLog wrote on release</a:t>
+              <a:t>$ python3 ~/opensearch_results.py --name opensearch_verify</a:t>
             </a:r>
           </a:p>
           <a:p>
@@ -16761,11 +16798,23 @@
             <a:r>
               <a:rPr sz="1250" b="0">
                 <a:solidFill>
+                  <a:srgbClr val="1B2B34"/>
+                </a:solidFill>
+                <a:latin typeface="Consolas"/>
+              </a:rPr>
+              <a:t>pav_id   name                                          result</a:t>
+            </a:r>
+          </a:p>
+          <a:p>
+            <a:pPr algn="l"/>
+            <a:r>
+              <a:rPr sz="1250" b="0">
+                <a:solidFill>
                   <a:srgbClr val="1E7D3C"/>
                 </a:solidFill>
                 <a:latin typeface="Consolas"/>
               </a:rPr>
-              <a:t>x1003c7s7b0n3,"pav_test result=PASS",pavilion,released</a:t>
+              <a:t>s75.1    opensearch_verify.os_pass                     PASS</a:t>
             </a:r>
           </a:p>
           <a:p>
@@ -16777,7 +16826,31 @@
                 </a:solidFill>
                 <a:latin typeface="Consolas"/>
               </a:rPr>
-              <a:t>x1003c7s7b0n1,x1003c7s7b0n2,x1003c7s7b0n3,"pav_test result=FAIL",pavilion,released</a:t>
+              <a:t>s75.2    opensearch_verify.os_fail                     FAIL</a:t>
+            </a:r>
+          </a:p>
+          <a:p>
+            <a:pPr algn="l"/>
+            <a:r>
+              <a:rPr sz="1250" b="0">
+                <a:solidFill>
+                  <a:srgbClr val="1E7D3C"/>
+                </a:solidFill>
+                <a:latin typeface="Consolas"/>
+              </a:rPr>
+              <a:t>s75.3    opensearch_verify.os_with_metrics             PASS</a:t>
+            </a:r>
+          </a:p>
+          <a:p>
+            <a:pPr algn="l"/>
+            <a:r>
+              <a:rPr sz="1250" b="0">
+                <a:solidFill>
+                  <a:srgbClr val="1E7D3C"/>
+                </a:solidFill>
+                <a:latin typeface="Consolas"/>
+              </a:rPr>
+              <a:t>s75.4    opensearch_verify.os_version_tag.v1.0-verify  PASS</a:t>
             </a:r>
           </a:p>
         </p:txBody>
@@ -16811,7 +16884,7 @@
                 </a:solidFill>
                 <a:latin typeface="Arial"/>
               </a:rPr>
-              <a:t>Run in Pavilion → jobs in PBS → saLog writes a CSV row as each node is released.</a:t>
+              <a:t>Shipped to OpenSearch, read back from the index — then on to Grafana dashboards.</a:t>
             </a:r>
           </a:p>
         </p:txBody>
@@ -16863,7 +16936,7 @@
                 </a:solidFill>
                 <a:latin typeface="Arial"/>
               </a:rPr>
-              <a:t>LIVE DEMO · L9</a:t>
+              <a:t>LIVE DEMO · L10</a:t>
             </a:r>
           </a:p>
         </p:txBody>
@@ -16897,7 +16970,7 @@
                 </a:solidFill>
                 <a:latin typeface="Arial"/>
               </a:rPr>
-              <a:t>Output plugin: OpenSearch → Grafana</a:t>
+              <a:t>Output plugin: MySQL</a:t>
             </a:r>
           </a:p>
         </p:txBody>
@@ -16992,7 +17065,7 @@
                 </a:solidFill>
                 <a:latin typeface="Arial"/>
               </a:rPr>
-              <a:t>▶  09-opensearch.sh</a:t>
+              <a:t>▶  10-mysql.sh</a:t>
             </a:r>
           </a:p>
         </p:txBody>
@@ -17046,7 +17119,7 @@
                 </a:solidFill>
                 <a:latin typeface="Consolas"/>
               </a:rPr>
-              <a:t>$ pav run -m pbs opensearch_verify        # 4 tests via PBS; each result → OpenSearch</a:t>
+              <a:t>$ pav run demo_pbs.metrics          # every logger fires, incl. mysql</a:t>
             </a:r>
           </a:p>
           <a:p>
@@ -17058,7 +17131,7 @@
                 </a:solidFill>
                 <a:latin typeface="Consolas"/>
               </a:rPr>
-              <a:t>created 4 tests, skipped 0, 0 errors.</a:t>
+              <a:t>sid: s71</a:t>
             </a:r>
           </a:p>
           <a:p>
@@ -17070,7 +17143,7 @@
                 </a:solidFill>
                 <a:latin typeface="Consolas"/>
               </a:rPr>
-              <a:t>sid: s75</a:t>
+              <a:t>tests: 1</a:t>
             </a:r>
           </a:p>
           <a:p>
@@ -17094,7 +17167,7 @@
                 </a:solidFill>
                 <a:latin typeface="Consolas"/>
               </a:rPr>
-              <a:t>$ qstat -a                                # through the scheduler</a:t>
+              <a:t>$ qstat -a                          # a real PBS job</a:t>
             </a:r>
           </a:p>
           <a:p>
@@ -17106,7 +17179,7 @@
                 </a:solidFill>
                 <a:latin typeface="Consolas"/>
               </a:rPr>
-              <a:t>8389.pbs-server pavilion workq pav_opens*  1  1  R</a:t>
+              <a:t>8384.pbs-server pavilion workq pav_demo_*  1  1  R</a:t>
             </a:r>
           </a:p>
           <a:p>
@@ -17130,7 +17203,8 @@
                 </a:solidFill>
                 <a:latin typeface="Consolas"/>
               </a:rPr>
-              <a:t>$ python3 ~/opensearch_results.py --name opensearch_verify</a:t>
+              <a:t>$ mysql pavilion -e 'SELECT pav_id,name,result,sys_name,ROUND(duration,3) dur
+                    FROM results ORDER BY logged_at DESC LIMIT 4'</a:t>
             </a:r>
           </a:p>
           <a:p>
@@ -17142,7 +17216,7 @@
                 </a:solidFill>
                 <a:latin typeface="Consolas"/>
               </a:rPr>
-              <a:t>pav_id   name                                          result</a:t>
+              <a:t>pav_id  name                  result  sys_name    dur</a:t>
             </a:r>
           </a:p>
           <a:p>
@@ -17154,7 +17228,7 @@
                 </a:solidFill>
                 <a:latin typeface="Consolas"/>
               </a:rPr>
-              <a:t>s75.1    opensearch_verify.os_pass                     PASS</a:t>
+              <a:t>s74.2   demo_pbs.metrics      PASS    pbs-server  0.040</a:t>
             </a:r>
           </a:p>
           <a:p>
@@ -17162,11 +17236,11 @@
             <a:r>
               <a:rPr sz="1250" b="0">
                 <a:solidFill>
-                  <a:srgbClr val="B32A2A"/>
-                </a:solidFill>
-                <a:latin typeface="Consolas"/>
-              </a:rPr>
-              <a:t>s75.2    opensearch_verify.os_fail                     FAIL</a:t>
+                  <a:srgbClr val="1E7D3C"/>
+                </a:solidFill>
+                <a:latin typeface="Consolas"/>
+              </a:rPr>
+              <a:t>s74.1   demo_pbs.pass         PASS    pbs-server  0.043</a:t>
             </a:r>
           </a:p>
           <a:p>
@@ -17178,7 +17252,7 @@
                 </a:solidFill>
                 <a:latin typeface="Consolas"/>
               </a:rPr>
-              <a:t>s75.3    opensearch_verify.os_with_metrics             PASS</a:t>
+              <a:t>s73.1   demo_modes.mode_demo  PASS    pbs-server  0.040</a:t>
             </a:r>
           </a:p>
           <a:p>
@@ -17190,7 +17264,7 @@
                 </a:solidFill>
                 <a:latin typeface="Consolas"/>
               </a:rPr>
-              <a:t>s75.4    opensearch_verify.os_version_tag.v1.0-verify  PASS</a:t>
+              <a:t>s72.3   demo_perms.matrix...  PASS    pbs-server  0.040</a:t>
             </a:r>
           </a:p>
         </p:txBody>
@@ -17224,7 +17298,7 @@
                 </a:solidFill>
                 <a:latin typeface="Arial"/>
               </a:rPr>
-              <a:t>Shipped to OpenSearch, read back from the index — then on to Grafana dashboards.</a:t>
+              <a:t>A result logger we wrote — every result lands in a MySQL table (passwordless local auth).</a:t>
             </a:r>
           </a:p>
         </p:txBody>
@@ -17276,7 +17350,7 @@
                 </a:solidFill>
                 <a:latin typeface="Arial"/>
               </a:rPr>
-              <a:t>LIVE DEMO · L10</a:t>
+              <a:t>RESULT LOGGERS</a:t>
             </a:r>
           </a:p>
         </p:txBody>
@@ -17310,7 +17384,7 @@
                 </a:solidFill>
                 <a:latin typeface="Arial"/>
               </a:rPr>
-              <a:t>Output plugin: MySQL</a:t>
+              <a:t>Export results anywhere</a:t>
             </a:r>
           </a:p>
         </p:txBody>
@@ -17360,265 +17434,14 @@
       </p:sp>
       <p:sp>
         <p:nvSpPr>
-          <p:cNvPr id="5" name="Rectangle 4"/>
-          <p:cNvSpPr/>
-          <p:nvPr/>
-        </p:nvSpPr>
-        <p:spPr>
-          <a:xfrm>
-            <a:off x="8503920" y="457200"/>
-            <a:ext cx="3108960" cy="502920"/>
-          </a:xfrm>
-          <a:prstGeom prst="rect">
-            <a:avLst/>
-          </a:prstGeom>
-          <a:solidFill>
-            <a:srgbClr val="2E6DA4"/>
-          </a:solidFill>
-          <a:ln>
-            <a:noFill/>
-          </a:ln>
-        </p:spPr>
-        <p:style>
-          <a:lnRef idx="1">
-            <a:schemeClr val="accent1"/>
-          </a:lnRef>
-          <a:fillRef idx="3">
-            <a:schemeClr val="accent1"/>
-          </a:fillRef>
-          <a:effectRef idx="2">
-            <a:schemeClr val="accent1"/>
-          </a:effectRef>
-          <a:fontRef idx="minor">
-            <a:schemeClr val="lt1"/>
-          </a:fontRef>
-        </p:style>
-        <p:txBody>
-          <a:bodyPr rtlCol="0" anchor="ctr" wrap="square"/>
-          <a:lstStyle/>
-          <a:p>
-            <a:pPr algn="ctr"/>
-            <a:r>
-              <a:rPr sz="1300" b="1">
-                <a:solidFill>
-                  <a:srgbClr val="FFFFFF"/>
-                </a:solidFill>
-                <a:latin typeface="Arial"/>
-              </a:rPr>
-              <a:t>▶  10-mysql.sh</a:t>
-            </a:r>
-          </a:p>
-        </p:txBody>
-      </p:sp>
-      <p:sp>
-        <p:nvSpPr>
-          <p:cNvPr id="6" name="Rectangle 5"/>
-          <p:cNvSpPr/>
-          <p:nvPr/>
-        </p:nvSpPr>
-        <p:spPr>
-          <a:xfrm>
-            <a:off x="640080" y="1645920"/>
-            <a:ext cx="10972800" cy="4343400"/>
-          </a:xfrm>
-          <a:prstGeom prst="rect">
-            <a:avLst/>
-          </a:prstGeom>
-          <a:solidFill>
-            <a:srgbClr val="F3F4F6"/>
-          </a:solidFill>
-          <a:ln w="12700">
-            <a:solidFill>
-              <a:srgbClr val="D5DAE0"/>
-            </a:solidFill>
-          </a:ln>
-        </p:spPr>
-        <p:style>
-          <a:lnRef idx="1">
-            <a:schemeClr val="accent1"/>
-          </a:lnRef>
-          <a:fillRef idx="3">
-            <a:schemeClr val="accent1"/>
-          </a:fillRef>
-          <a:effectRef idx="2">
-            <a:schemeClr val="accent1"/>
-          </a:effectRef>
-          <a:fontRef idx="minor">
-            <a:schemeClr val="lt1"/>
-          </a:fontRef>
-        </p:style>
-        <p:txBody>
-          <a:bodyPr rtlCol="0" anchor="t" wrap="square" lIns="228600" tIns="146304"/>
-          <a:lstStyle/>
-          <a:p>
-            <a:pPr algn="l"/>
-            <a:r>
-              <a:rPr sz="1400" b="1">
-                <a:solidFill>
-                  <a:srgbClr val="2E6DA4"/>
-                </a:solidFill>
-                <a:latin typeface="Consolas"/>
-              </a:rPr>
-              <a:t>$ pav run demo_pbs.metrics          # every logger fires, incl. mysql</a:t>
-            </a:r>
-          </a:p>
-          <a:p>
-            <a:pPr algn="l"/>
-            <a:r>
-              <a:rPr sz="1250" b="0">
-                <a:solidFill>
-                  <a:srgbClr val="1B2B34"/>
-                </a:solidFill>
-                <a:latin typeface="Consolas"/>
-              </a:rPr>
-              <a:t>sid: s71</a:t>
-            </a:r>
-          </a:p>
-          <a:p>
-            <a:pPr algn="l"/>
-            <a:r>
-              <a:rPr sz="1250" b="0">
-                <a:solidFill>
-                  <a:srgbClr val="1B2B34"/>
-                </a:solidFill>
-                <a:latin typeface="Consolas"/>
-              </a:rPr>
-              <a:t>tests: 1</a:t>
-            </a:r>
-          </a:p>
-          <a:p>
-            <a:pPr algn="l"/>
-            <a:r>
-              <a:rPr sz="1250" b="0">
-                <a:solidFill>
-                  <a:srgbClr val="1B2B34"/>
-                </a:solidFill>
-                <a:latin typeface="Consolas"/>
-              </a:rPr>
-              <a:t> </a:t>
-            </a:r>
-          </a:p>
-          <a:p>
-            <a:pPr algn="l"/>
-            <a:r>
-              <a:rPr sz="1400" b="1">
-                <a:solidFill>
-                  <a:srgbClr val="2E6DA4"/>
-                </a:solidFill>
-                <a:latin typeface="Consolas"/>
-              </a:rPr>
-              <a:t>$ qstat -a                          # a real PBS job</a:t>
-            </a:r>
-          </a:p>
-          <a:p>
-            <a:pPr algn="l"/>
-            <a:r>
-              <a:rPr sz="1250" b="0">
-                <a:solidFill>
-                  <a:srgbClr val="1B2B34"/>
-                </a:solidFill>
-                <a:latin typeface="Consolas"/>
-              </a:rPr>
-              <a:t>8384.pbs-server pavilion workq pav_demo_*  1  1  R</a:t>
-            </a:r>
-          </a:p>
-          <a:p>
-            <a:pPr algn="l"/>
-            <a:r>
-              <a:rPr sz="1250" b="0">
-                <a:solidFill>
-                  <a:srgbClr val="1B2B34"/>
-                </a:solidFill>
-                <a:latin typeface="Consolas"/>
-              </a:rPr>
-              <a:t> </a:t>
-            </a:r>
-          </a:p>
-          <a:p>
-            <a:pPr algn="l"/>
-            <a:r>
-              <a:rPr sz="1400" b="1">
-                <a:solidFill>
-                  <a:srgbClr val="2E6DA4"/>
-                </a:solidFill>
-                <a:latin typeface="Consolas"/>
-              </a:rPr>
-              <a:t>$ mysql pavilion -e 'SELECT pav_id,name,result,sys_name,ROUND(duration,3) dur
-                    FROM results ORDER BY logged_at DESC LIMIT 4'</a:t>
-            </a:r>
-          </a:p>
-          <a:p>
-            <a:pPr algn="l"/>
-            <a:r>
-              <a:rPr sz="1250" b="0">
-                <a:solidFill>
-                  <a:srgbClr val="1B2B34"/>
-                </a:solidFill>
-                <a:latin typeface="Consolas"/>
-              </a:rPr>
-              <a:t>pav_id  name                  result  sys_name    dur</a:t>
-            </a:r>
-          </a:p>
-          <a:p>
-            <a:pPr algn="l"/>
-            <a:r>
-              <a:rPr sz="1250" b="0">
-                <a:solidFill>
-                  <a:srgbClr val="1E7D3C"/>
-                </a:solidFill>
-                <a:latin typeface="Consolas"/>
-              </a:rPr>
-              <a:t>s74.2   demo_pbs.metrics      PASS    pbs-server  0.040</a:t>
-            </a:r>
-          </a:p>
-          <a:p>
-            <a:pPr algn="l"/>
-            <a:r>
-              <a:rPr sz="1250" b="0">
-                <a:solidFill>
-                  <a:srgbClr val="1E7D3C"/>
-                </a:solidFill>
-                <a:latin typeface="Consolas"/>
-              </a:rPr>
-              <a:t>s74.1   demo_pbs.pass         PASS    pbs-server  0.043</a:t>
-            </a:r>
-          </a:p>
-          <a:p>
-            <a:pPr algn="l"/>
-            <a:r>
-              <a:rPr sz="1250" b="0">
-                <a:solidFill>
-                  <a:srgbClr val="1E7D3C"/>
-                </a:solidFill>
-                <a:latin typeface="Consolas"/>
-              </a:rPr>
-              <a:t>s73.1   demo_modes.mode_demo  PASS    pbs-server  0.040</a:t>
-            </a:r>
-          </a:p>
-          <a:p>
-            <a:pPr algn="l"/>
-            <a:r>
-              <a:rPr sz="1250" b="0">
-                <a:solidFill>
-                  <a:srgbClr val="1E7D3C"/>
-                </a:solidFill>
-                <a:latin typeface="Consolas"/>
-              </a:rPr>
-              <a:t>s72.3   demo_perms.matrix...  PASS    pbs-server  0.040</a:t>
-            </a:r>
-          </a:p>
-        </p:txBody>
-      </p:sp>
-      <p:sp>
-        <p:nvSpPr>
-          <p:cNvPr id="7" name="TextBox 6"/>
+          <p:cNvPr id="5" name="TextBox 4"/>
           <p:cNvSpPr txBox="1"/>
           <p:nvPr/>
         </p:nvSpPr>
         <p:spPr>
           <a:xfrm>
-            <a:off x="640080" y="6144768"/>
-            <a:ext cx="10972800" cy="502920"/>
+            <a:off x="640080" y="1691640"/>
+            <a:ext cx="10972800" cy="4754880"/>
           </a:xfrm>
           <a:prstGeom prst="rect">
             <a:avLst/>
@@ -17631,14 +17454,83 @@
           </a:bodyPr>
           <a:lstStyle/>
           <a:p>
-            <a:r>
-              <a:rPr sz="1400" b="0">
-                <a:solidFill>
-                  <a:srgbClr val="5B6674"/>
-                </a:solidFill>
-                <a:latin typeface="Arial"/>
-              </a:rPr>
-              <a:t>A result logger we wrote — every result lands in a MySQL table (passwordless local auth).</a:t>
+            <a:pPr>
+              <a:spcAft>
+                <a:spcPts val="1000"/>
+              </a:spcAft>
+            </a:pPr>
+            <a:r>
+              <a:rPr sz="2000" b="0">
+                <a:solidFill>
+                  <a:srgbClr val="21252B"/>
+                </a:solidFill>
+                <a:latin typeface="Arial"/>
+              </a:rPr>
+              <a:t>•  Grafana — live dashboards &amp; trends  (shown today).</a:t>
+            </a:r>
+          </a:p>
+          <a:p>
+            <a:pPr>
+              <a:spcAft>
+                <a:spcPts val="1000"/>
+              </a:spcAft>
+            </a:pPr>
+            <a:r>
+              <a:rPr sz="2000" b="0">
+                <a:solidFill>
+                  <a:srgbClr val="21252B"/>
+                </a:solidFill>
+                <a:latin typeface="Arial"/>
+              </a:rPr>
+              <a:t>•  OpenSearch — index every result document  (shown today).</a:t>
+            </a:r>
+          </a:p>
+          <a:p>
+            <a:pPr>
+              <a:spcAft>
+                <a:spcPts val="1000"/>
+              </a:spcAft>
+            </a:pPr>
+            <a:r>
+              <a:rPr sz="2000" b="0">
+                <a:solidFill>
+                  <a:srgbClr val="21252B"/>
+                </a:solidFill>
+                <a:latin typeface="Arial"/>
+              </a:rPr>
+              <a:t>•  MySQL — a row per result in a relational table  (shown today).</a:t>
+            </a:r>
+          </a:p>
+          <a:p>
+            <a:pPr>
+              <a:spcAft>
+                <a:spcPts val="1000"/>
+              </a:spcAft>
+            </a:pPr>
+            <a:r>
+              <a:rPr sz="2000" b="0">
+                <a:solidFill>
+                  <a:srgbClr val="21252B"/>
+                </a:solidFill>
+                <a:latin typeface="Arial"/>
+              </a:rPr>
+              <a:t>•  PostgreSQL — same idea, for a Postgres shop.</a:t>
+            </a:r>
+          </a:p>
+          <a:p>
+            <a:pPr>
+              <a:spcAft>
+                <a:spcPts val="1000"/>
+              </a:spcAft>
+            </a:pPr>
+            <a:r>
+              <a:rPr sz="2000" b="0">
+                <a:solidFill>
+                  <a:srgbClr val="21252B"/>
+                </a:solidFill>
+                <a:latin typeface="Arial"/>
+              </a:rPr>
+              <a:t>•  [add your own] — a result logger is just a plugin: target any destination.</a:t>
             </a:r>
           </a:p>
         </p:txBody>
@@ -17663,88 +17555,20 @@
       <p:grpSpPr/>
       <p:sp>
         <p:nvSpPr>
-          <p:cNvPr id="2" name="TextBox 1"/>
-          <p:cNvSpPr txBox="1"/>
-          <p:nvPr/>
-        </p:nvSpPr>
-        <p:spPr>
-          <a:xfrm>
-            <a:off x="548640" y="320040"/>
-            <a:ext cx="7680960" cy="365760"/>
-          </a:xfrm>
-          <a:prstGeom prst="rect">
-            <a:avLst/>
-          </a:prstGeom>
-          <a:noFill/>
-        </p:spPr>
-        <p:txBody>
-          <a:bodyPr wrap="square">
-            <a:spAutoFit/>
-          </a:bodyPr>
-          <a:lstStyle/>
-          <a:p>
-            <a:r>
-              <a:rPr sz="1200" b="1">
-                <a:solidFill>
-                  <a:srgbClr val="2E6DA4"/>
-                </a:solidFill>
-                <a:latin typeface="Arial"/>
-              </a:rPr>
-              <a:t>RESULT LOGGERS</a:t>
-            </a:r>
-          </a:p>
-        </p:txBody>
-      </p:sp>
-      <p:sp>
-        <p:nvSpPr>
-          <p:cNvPr id="3" name="TextBox 2"/>
-          <p:cNvSpPr txBox="1"/>
-          <p:nvPr/>
-        </p:nvSpPr>
-        <p:spPr>
-          <a:xfrm>
-            <a:off x="548640" y="640080"/>
-            <a:ext cx="11064240" cy="822960"/>
-          </a:xfrm>
-          <a:prstGeom prst="rect">
-            <a:avLst/>
-          </a:prstGeom>
-          <a:noFill/>
-        </p:spPr>
-        <p:txBody>
-          <a:bodyPr wrap="square">
-            <a:spAutoFit/>
-          </a:bodyPr>
-          <a:lstStyle/>
-          <a:p>
-            <a:r>
-              <a:rPr sz="3000" b="1">
-                <a:solidFill>
-                  <a:srgbClr val="1F3B63"/>
-                </a:solidFill>
-                <a:latin typeface="Arial"/>
-              </a:rPr>
-              <a:t>Export results anywhere</a:t>
-            </a:r>
-          </a:p>
-        </p:txBody>
-      </p:sp>
-      <p:sp>
-        <p:nvSpPr>
-          <p:cNvPr id="4" name="Rectangle 3"/>
+          <p:cNvPr id="2" name="Rectangle 1"/>
           <p:cNvSpPr/>
           <p:nvPr/>
         </p:nvSpPr>
         <p:spPr>
           <a:xfrm>
-            <a:off x="566928" y="1417320"/>
-            <a:ext cx="2011680" cy="38100"/>
+            <a:off x="0" y="2651760"/>
+            <a:ext cx="12191695" cy="1554480"/>
           </a:xfrm>
           <a:prstGeom prst="rect">
             <a:avLst/>
           </a:prstGeom>
           <a:solidFill>
-            <a:srgbClr val="2E6DA4"/>
+            <a:srgbClr val="EEF2F7"/>
           </a:solidFill>
           <a:ln>
             <a:noFill/>
@@ -17774,14 +17598,14 @@
       </p:sp>
       <p:sp>
         <p:nvSpPr>
-          <p:cNvPr id="5" name="TextBox 4"/>
+          <p:cNvPr id="3" name="TextBox 2"/>
           <p:cNvSpPr txBox="1"/>
           <p:nvPr/>
         </p:nvSpPr>
         <p:spPr>
           <a:xfrm>
-            <a:off x="640080" y="1691640"/>
-            <a:ext cx="10972800" cy="4754880"/>
+            <a:off x="731520" y="2834640"/>
+            <a:ext cx="10698480" cy="1188720"/>
           </a:xfrm>
           <a:prstGeom prst="rect">
             <a:avLst/>
@@ -17794,83 +17618,25 @@
           </a:bodyPr>
           <a:lstStyle/>
           <a:p>
-            <a:pPr>
-              <a:spcAft>
-                <a:spcPts val="1000"/>
-              </a:spcAft>
-            </a:pPr>
-            <a:r>
-              <a:rPr sz="2000" b="0">
-                <a:solidFill>
-                  <a:srgbClr val="21252B"/>
-                </a:solidFill>
-                <a:latin typeface="Arial"/>
-              </a:rPr>
-              <a:t>•  Grafana — live dashboards &amp; trends  (shown today).</a:t>
-            </a:r>
-          </a:p>
-          <a:p>
-            <a:pPr>
-              <a:spcAft>
-                <a:spcPts val="1000"/>
-              </a:spcAft>
-            </a:pPr>
-            <a:r>
-              <a:rPr sz="2000" b="0">
-                <a:solidFill>
-                  <a:srgbClr val="21252B"/>
-                </a:solidFill>
-                <a:latin typeface="Arial"/>
-              </a:rPr>
-              <a:t>•  OpenSearch — index every result document  (shown today).</a:t>
-            </a:r>
-          </a:p>
-          <a:p>
-            <a:pPr>
-              <a:spcAft>
-                <a:spcPts val="1000"/>
-              </a:spcAft>
-            </a:pPr>
-            <a:r>
-              <a:rPr sz="2000" b="0">
-                <a:solidFill>
-                  <a:srgbClr val="21252B"/>
-                </a:solidFill>
-                <a:latin typeface="Arial"/>
-              </a:rPr>
-              <a:t>•  MySQL — a row per result in a relational table  (shown today).</a:t>
-            </a:r>
-          </a:p>
-          <a:p>
-            <a:pPr>
-              <a:spcAft>
-                <a:spcPts val="1000"/>
-              </a:spcAft>
-            </a:pPr>
-            <a:r>
-              <a:rPr sz="2000" b="0">
-                <a:solidFill>
-                  <a:srgbClr val="21252B"/>
-                </a:solidFill>
-                <a:latin typeface="Arial"/>
-              </a:rPr>
-              <a:t>•  PostgreSQL — same idea, for a Postgres shop.</a:t>
-            </a:r>
-          </a:p>
-          <a:p>
-            <a:pPr>
-              <a:spcAft>
-                <a:spcPts val="1000"/>
-              </a:spcAft>
-            </a:pPr>
-            <a:r>
-              <a:rPr sz="2000" b="0">
-                <a:solidFill>
-                  <a:srgbClr val="21252B"/>
-                </a:solidFill>
-                <a:latin typeface="Arial"/>
-              </a:rPr>
-              <a:t>•  [add your own] — a result logger is just a plugin: target any destination.</a:t>
+            <a:r>
+              <a:rPr sz="1300" b="1">
+                <a:solidFill>
+                  <a:srgbClr val="2E6DA4"/>
+                </a:solidFill>
+                <a:latin typeface="Arial"/>
+              </a:rPr>
+              <a:t>REAL-WORLD</a:t>
+            </a:r>
+          </a:p>
+          <a:p>
+            <a:r>
+              <a:rPr sz="3600" b="1">
+                <a:solidFill>
+                  <a:srgbClr val="1F3B63"/>
+                </a:solidFill>
+                <a:latin typeface="Arial"/>
+              </a:rPr>
+              <a:t>Putting it together</a:t>
             </a:r>
           </a:p>
         </p:txBody>
@@ -17895,20 +17661,88 @@
       <p:grpSpPr/>
       <p:sp>
         <p:nvSpPr>
-          <p:cNvPr id="2" name="Rectangle 1"/>
+          <p:cNvPr id="2" name="TextBox 1"/>
+          <p:cNvSpPr txBox="1"/>
+          <p:nvPr/>
+        </p:nvSpPr>
+        <p:spPr>
+          <a:xfrm>
+            <a:off x="548640" y="320040"/>
+            <a:ext cx="7680960" cy="365760"/>
+          </a:xfrm>
+          <a:prstGeom prst="rect">
+            <a:avLst/>
+          </a:prstGeom>
+          <a:noFill/>
+        </p:spPr>
+        <p:txBody>
+          <a:bodyPr wrap="square">
+            <a:spAutoFit/>
+          </a:bodyPr>
+          <a:lstStyle/>
+          <a:p>
+            <a:r>
+              <a:rPr sz="1200" b="1">
+                <a:solidFill>
+                  <a:srgbClr val="2E6DA4"/>
+                </a:solidFill>
+                <a:latin typeface="Arial"/>
+              </a:rPr>
+              <a:t>IN PRACTICE</a:t>
+            </a:r>
+          </a:p>
+        </p:txBody>
+      </p:sp>
+      <p:sp>
+        <p:nvSpPr>
+          <p:cNvPr id="3" name="TextBox 2"/>
+          <p:cNvSpPr txBox="1"/>
+          <p:nvPr/>
+        </p:nvSpPr>
+        <p:spPr>
+          <a:xfrm>
+            <a:off x="548640" y="640080"/>
+            <a:ext cx="11064240" cy="822960"/>
+          </a:xfrm>
+          <a:prstGeom prst="rect">
+            <a:avLst/>
+          </a:prstGeom>
+          <a:noFill/>
+        </p:spPr>
+        <p:txBody>
+          <a:bodyPr wrap="square">
+            <a:spAutoFit/>
+          </a:bodyPr>
+          <a:lstStyle/>
+          <a:p>
+            <a:r>
+              <a:rPr sz="3000" b="1">
+                <a:solidFill>
+                  <a:srgbClr val="1F3B63"/>
+                </a:solidFill>
+                <a:latin typeface="Arial"/>
+              </a:rPr>
+              <a:t>How we use it here</a:t>
+            </a:r>
+          </a:p>
+        </p:txBody>
+      </p:sp>
+      <p:sp>
+        <p:nvSpPr>
+          <p:cNvPr id="4" name="Rectangle 3"/>
           <p:cNvSpPr/>
           <p:nvPr/>
         </p:nvSpPr>
         <p:spPr>
           <a:xfrm>
-            <a:off x="0" y="2651760"/>
-            <a:ext cx="12191695" cy="1554480"/>
+            <a:off x="566928" y="1417320"/>
+            <a:ext cx="2011680" cy="38100"/>
           </a:xfrm>
           <a:prstGeom prst="rect">
             <a:avLst/>
           </a:prstGeom>
           <a:solidFill>
-            <a:srgbClr val="EEF2F7"/>
+            <a:srgbClr val="2E6DA4"/>
           </a:solidFill>
           <a:ln>
             <a:noFill/>
@@ -17938,14 +17772,14 @@
       </p:sp>
       <p:sp>
         <p:nvSpPr>
-          <p:cNvPr id="3" name="TextBox 2"/>
+          <p:cNvPr id="5" name="TextBox 4"/>
           <p:cNvSpPr txBox="1"/>
           <p:nvPr/>
         </p:nvSpPr>
         <p:spPr>
           <a:xfrm>
-            <a:off x="731520" y="2834640"/>
-            <a:ext cx="10698480" cy="1188720"/>
+            <a:off x="640080" y="1691640"/>
+            <a:ext cx="10972800" cy="4754880"/>
           </a:xfrm>
           <a:prstGeom prst="rect">
             <a:avLst/>
@@ -17958,25 +17792,67 @@
           </a:bodyPr>
           <a:lstStyle/>
           <a:p>
-            <a:r>
-              <a:rPr sz="1300" b="1">
-                <a:solidFill>
-                  <a:srgbClr val="2E6DA4"/>
-                </a:solidFill>
-                <a:latin typeface="Arial"/>
-              </a:rPr>
-              <a:t>REAL-WORLD</a:t>
-            </a:r>
-          </a:p>
-          <a:p>
-            <a:r>
-              <a:rPr sz="3600" b="1">
-                <a:solidFill>
-                  <a:srgbClr val="1F3B63"/>
-                </a:solidFill>
-                <a:latin typeface="Arial"/>
-              </a:rPr>
-              <a:t>Putting it together</a:t>
+            <a:pPr>
+              <a:spcAft>
+                <a:spcPts val="1000"/>
+              </a:spcAft>
+            </a:pPr>
+            <a:r>
+              <a:rPr sz="2000" b="0">
+                <a:solidFill>
+                  <a:srgbClr val="21252B"/>
+                </a:solidFill>
+                <a:latin typeface="Arial"/>
+              </a:rPr>
+              <a:t>•  Define acceptance/regression tests once (incl. real benchmarks: HPL, HPCG).</a:t>
+            </a:r>
+          </a:p>
+          <a:p>
+            <a:pPr>
+              <a:spcAft>
+                <a:spcPts val="1000"/>
+              </a:spcAft>
+            </a:pPr>
+            <a:r>
+              <a:rPr sz="2000" b="0">
+                <a:solidFill>
+                  <a:srgbClr val="21252B"/>
+                </a:solidFill>
+                <a:latin typeface="Arial"/>
+              </a:rPr>
+              <a:t>•  Run through PBS across the cluster; permute across configurations.</a:t>
+            </a:r>
+          </a:p>
+          <a:p>
+            <a:pPr>
+              <a:spcAft>
+                <a:spcPts val="1000"/>
+              </a:spcAft>
+            </a:pPr>
+            <a:r>
+              <a:rPr sz="2000" b="0">
+                <a:solidFill>
+                  <a:srgbClr val="21252B"/>
+                </a:solidFill>
+                <a:latin typeface="Arial"/>
+              </a:rPr>
+              <a:t>•  Parse metrics; every result flows to CSV + OpenSearch automatically.</a:t>
+            </a:r>
+          </a:p>
+          <a:p>
+            <a:pPr>
+              <a:spcAft>
+                <a:spcPts val="1000"/>
+              </a:spcAft>
+            </a:pPr>
+            <a:r>
+              <a:rPr sz="2000" b="0">
+                <a:solidFill>
+                  <a:srgbClr val="21252B"/>
+                </a:solidFill>
+                <a:latin typeface="Arial"/>
+              </a:rPr>
+              <a:t>•  Grafana dashboards make trends and regressions visible over time.</a:t>
             </a:r>
           </a:p>
         </p:txBody>
@@ -17990,222 +17866,6 @@
 </file>
 
 <file path=ppt/slides/slide48.xml><?xml version="1.0" encoding="utf-8"?>
-<p:sld xmlns:a="http://schemas.openxmlformats.org/drawingml/2006/main" xmlns:p="http://schemas.openxmlformats.org/presentationml/2006/main" xmlns:r="http://schemas.openxmlformats.org/officeDocument/2006/relationships">
-  <p:cSld>
-    <p:spTree>
-      <p:nvGrpSpPr>
-        <p:cNvPr id="1" name=""/>
-        <p:cNvGrpSpPr/>
-        <p:nvPr/>
-      </p:nvGrpSpPr>
-      <p:grpSpPr/>
-      <p:sp>
-        <p:nvSpPr>
-          <p:cNvPr id="2" name="TextBox 1"/>
-          <p:cNvSpPr txBox="1"/>
-          <p:nvPr/>
-        </p:nvSpPr>
-        <p:spPr>
-          <a:xfrm>
-            <a:off x="548640" y="320040"/>
-            <a:ext cx="7680960" cy="365760"/>
-          </a:xfrm>
-          <a:prstGeom prst="rect">
-            <a:avLst/>
-          </a:prstGeom>
-          <a:noFill/>
-        </p:spPr>
-        <p:txBody>
-          <a:bodyPr wrap="square">
-            <a:spAutoFit/>
-          </a:bodyPr>
-          <a:lstStyle/>
-          <a:p>
-            <a:r>
-              <a:rPr sz="1200" b="1">
-                <a:solidFill>
-                  <a:srgbClr val="2E6DA4"/>
-                </a:solidFill>
-                <a:latin typeface="Arial"/>
-              </a:rPr>
-              <a:t>IN PRACTICE</a:t>
-            </a:r>
-          </a:p>
-        </p:txBody>
-      </p:sp>
-      <p:sp>
-        <p:nvSpPr>
-          <p:cNvPr id="3" name="TextBox 2"/>
-          <p:cNvSpPr txBox="1"/>
-          <p:nvPr/>
-        </p:nvSpPr>
-        <p:spPr>
-          <a:xfrm>
-            <a:off x="548640" y="640080"/>
-            <a:ext cx="11064240" cy="822960"/>
-          </a:xfrm>
-          <a:prstGeom prst="rect">
-            <a:avLst/>
-          </a:prstGeom>
-          <a:noFill/>
-        </p:spPr>
-        <p:txBody>
-          <a:bodyPr wrap="square">
-            <a:spAutoFit/>
-          </a:bodyPr>
-          <a:lstStyle/>
-          <a:p>
-            <a:r>
-              <a:rPr sz="3000" b="1">
-                <a:solidFill>
-                  <a:srgbClr val="1F3B63"/>
-                </a:solidFill>
-                <a:latin typeface="Arial"/>
-              </a:rPr>
-              <a:t>How we use it here</a:t>
-            </a:r>
-          </a:p>
-        </p:txBody>
-      </p:sp>
-      <p:sp>
-        <p:nvSpPr>
-          <p:cNvPr id="4" name="Rectangle 3"/>
-          <p:cNvSpPr/>
-          <p:nvPr/>
-        </p:nvSpPr>
-        <p:spPr>
-          <a:xfrm>
-            <a:off x="566928" y="1417320"/>
-            <a:ext cx="2011680" cy="38100"/>
-          </a:xfrm>
-          <a:prstGeom prst="rect">
-            <a:avLst/>
-          </a:prstGeom>
-          <a:solidFill>
-            <a:srgbClr val="2E6DA4"/>
-          </a:solidFill>
-          <a:ln>
-            <a:noFill/>
-          </a:ln>
-        </p:spPr>
-        <p:style>
-          <a:lnRef idx="1">
-            <a:schemeClr val="accent1"/>
-          </a:lnRef>
-          <a:fillRef idx="3">
-            <a:schemeClr val="accent1"/>
-          </a:fillRef>
-          <a:effectRef idx="2">
-            <a:schemeClr val="accent1"/>
-          </a:effectRef>
-          <a:fontRef idx="minor">
-            <a:schemeClr val="lt1"/>
-          </a:fontRef>
-        </p:style>
-        <p:txBody>
-          <a:bodyPr rtlCol="0" anchor="ctr"/>
-          <a:lstStyle/>
-          <a:p>
-            <a:pPr algn="ctr"/>
-          </a:p>
-        </p:txBody>
-      </p:sp>
-      <p:sp>
-        <p:nvSpPr>
-          <p:cNvPr id="5" name="TextBox 4"/>
-          <p:cNvSpPr txBox="1"/>
-          <p:nvPr/>
-        </p:nvSpPr>
-        <p:spPr>
-          <a:xfrm>
-            <a:off x="640080" y="1691640"/>
-            <a:ext cx="10972800" cy="4754880"/>
-          </a:xfrm>
-          <a:prstGeom prst="rect">
-            <a:avLst/>
-          </a:prstGeom>
-          <a:noFill/>
-        </p:spPr>
-        <p:txBody>
-          <a:bodyPr wrap="square">
-            <a:spAutoFit/>
-          </a:bodyPr>
-          <a:lstStyle/>
-          <a:p>
-            <a:pPr>
-              <a:spcAft>
-                <a:spcPts val="1000"/>
-              </a:spcAft>
-            </a:pPr>
-            <a:r>
-              <a:rPr sz="2000" b="0">
-                <a:solidFill>
-                  <a:srgbClr val="21252B"/>
-                </a:solidFill>
-                <a:latin typeface="Arial"/>
-              </a:rPr>
-              <a:t>•  Define acceptance/regression tests once (incl. real benchmarks: HPL, HPCG).</a:t>
-            </a:r>
-          </a:p>
-          <a:p>
-            <a:pPr>
-              <a:spcAft>
-                <a:spcPts val="1000"/>
-              </a:spcAft>
-            </a:pPr>
-            <a:r>
-              <a:rPr sz="2000" b="0">
-                <a:solidFill>
-                  <a:srgbClr val="21252B"/>
-                </a:solidFill>
-                <a:latin typeface="Arial"/>
-              </a:rPr>
-              <a:t>•  Run through PBS across the cluster; permute across configurations.</a:t>
-            </a:r>
-          </a:p>
-          <a:p>
-            <a:pPr>
-              <a:spcAft>
-                <a:spcPts val="1000"/>
-              </a:spcAft>
-            </a:pPr>
-            <a:r>
-              <a:rPr sz="2000" b="0">
-                <a:solidFill>
-                  <a:srgbClr val="21252B"/>
-                </a:solidFill>
-                <a:latin typeface="Arial"/>
-              </a:rPr>
-              <a:t>•  Parse metrics; every result flows to CSV + OpenSearch automatically.</a:t>
-            </a:r>
-          </a:p>
-          <a:p>
-            <a:pPr>
-              <a:spcAft>
-                <a:spcPts val="1000"/>
-              </a:spcAft>
-            </a:pPr>
-            <a:r>
-              <a:rPr sz="2000" b="0">
-                <a:solidFill>
-                  <a:srgbClr val="21252B"/>
-                </a:solidFill>
-                <a:latin typeface="Arial"/>
-              </a:rPr>
-              <a:t>•  Grafana dashboards make trends and regressions visible over time.</a:t>
-            </a:r>
-          </a:p>
-        </p:txBody>
-      </p:sp>
-    </p:spTree>
-  </p:cSld>
-  <p:clrMapOvr>
-    <a:masterClrMapping/>
-  </p:clrMapOvr>
-</p:sld>
-</file>
-
-<file path=ppt/slides/slide49.xml><?xml version="1.0" encoding="utf-8"?>
 <p:sld xmlns:a="http://schemas.openxmlformats.org/drawingml/2006/main" xmlns:p="http://schemas.openxmlformats.org/presentationml/2006/main" xmlns:r="http://schemas.openxmlformats.org/officeDocument/2006/relationships">
   <p:cSld>
     <p:spTree>

</xml_diff>